<commit_message>
Unify final delivery as 12-page presentation PDF with index
Replace the oversized report+slides pair with a single Presentación
Final (PPTX→PDF), regenerate compact figures, and fix image aspect
ratios for readable charts.

Co-authored-by: Cursor <cursoragent@cursor.com>
</commit_message>
<xml_diff>
--- a/reports/Presentacion_Final_Grupo33.pptx
+++ b/reports/Presentacion_Final_Grupo33.pptx
@@ -3150,8 +3150,8 @@
         </p:nvSpPr>
         <p:spPr>
           <a:xfrm>
-            <a:off x="731520" y="1645920"/>
-            <a:ext cx="10515600" cy="3657600"/>
+            <a:off x="731520" y="1371600"/>
+            <a:ext cx="10698480" cy="4389120"/>
           </a:xfrm>
           <a:prstGeom prst="rect">
             <a:avLst/>
@@ -3159,62 +3159,93 @@
           <a:noFill/>
         </p:spPr>
         <p:txBody>
-          <a:bodyPr wrap="none">
+          <a:bodyPr wrap="square">
             <a:spAutoFit/>
           </a:bodyPr>
           <a:lstStyle/>
           <a:p>
             <a:pPr algn="ctr">
               <a:spcAft>
-                <a:spcPts val="800"/>
-              </a:spcAft>
-            </a:pPr>
-            <a:r>
-              <a:rPr sz="1600" b="0">
+                <a:spcPts val="400"/>
+              </a:spcAft>
+            </a:pPr>
+            <a:r>
+              <a:rPr sz="1400" b="0">
                 <a:solidFill>
                   <a:srgbClr val="FFFFFF"/>
                 </a:solidFill>
                 <a:latin typeface="Calibri"/>
               </a:rPr>
-              <a:t>PROYECTO FINAL INTEGRADOR</a:t>
+              <a:t>DIPLOMADO EN CIENCIA DE DATOS Y ANÁLISIS AVANZADO</a:t>
             </a:r>
           </a:p>
           <a:p>
             <a:pPr algn="ctr">
               <a:spcAft>
-                <a:spcPts val="800"/>
-              </a:spcAft>
-            </a:pPr>
-            <a:r>
-              <a:rPr sz="3200" b="1">
+                <a:spcPts val="400"/>
+              </a:spcAft>
+            </a:pPr>
+            <a:r>
+              <a:rPr sz="1400" b="0">
                 <a:solidFill>
                   <a:srgbClr val="FFFFFF"/>
                 </a:solidFill>
                 <a:latin typeface="Calibri"/>
               </a:rPr>
-              <a:t>Detección de Fraude en Tarjetas de Crédito</a:t>
+              <a:t>Unidad N° 9 — Proyecto Final Integrador</a:t>
             </a:r>
           </a:p>
           <a:p>
             <a:pPr algn="ctr">
               <a:spcAft>
-                <a:spcPts val="800"/>
-              </a:spcAft>
-            </a:pPr>
-            <a:r>
-              <a:rPr sz="2000" b="1">
+                <a:spcPts val="400"/>
+              </a:spcAft>
+            </a:pPr>
+          </a:p>
+          <a:p>
+            <a:pPr algn="ctr">
+              <a:spcAft>
+                <a:spcPts val="400"/>
+              </a:spcAft>
+            </a:pPr>
+            <a:r>
+              <a:rPr sz="3400" b="1">
                 <a:solidFill>
                   <a:srgbClr val="FFFFFF"/>
                 </a:solidFill>
                 <a:latin typeface="Calibri"/>
               </a:rPr>
-              <a:t>Grupo 33</a:t>
+              <a:t>Detección de Fraude
+en Tarjetas de Crédito</a:t>
             </a:r>
           </a:p>
           <a:p>
             <a:pPr algn="ctr">
               <a:spcAft>
-                <a:spcPts val="800"/>
+                <a:spcPts val="400"/>
+              </a:spcAft>
+            </a:pPr>
+          </a:p>
+          <a:p>
+            <a:pPr algn="ctr">
+              <a:spcAft>
+                <a:spcPts val="400"/>
+              </a:spcAft>
+            </a:pPr>
+            <a:r>
+              <a:rPr sz="1800" b="1">
+                <a:solidFill>
+                  <a:srgbClr val="FFFFFF"/>
+                </a:solidFill>
+                <a:latin typeface="Calibri"/>
+              </a:rPr>
+              <a:t>Presentación Final del Proyecto — Grupo 33</a:t>
+            </a:r>
+          </a:p>
+          <a:p>
+            <a:pPr algn="ctr">
+              <a:spcAft>
+                <a:spcPts val="400"/>
               </a:spcAft>
             </a:pPr>
             <a:r>
@@ -3230,7 +3261,7 @@
           <a:p>
             <a:pPr algn="ctr">
               <a:spcAft>
-                <a:spcPts val="800"/>
+                <a:spcPts val="400"/>
               </a:spcAft>
             </a:pPr>
             <a:r>
@@ -3246,7 +3277,7 @@
           <a:p>
             <a:pPr algn="ctr">
               <a:spcAft>
-                <a:spcPts val="800"/>
+                <a:spcPts val="400"/>
               </a:spcAft>
             </a:pPr>
             <a:r>
@@ -3288,7 +3319,7 @@
         <p:spPr>
           <a:xfrm>
             <a:off x="0" y="0"/>
-            <a:ext cx="12191695" cy="822960"/>
+            <a:ext cx="12191695" cy="777240"/>
           </a:xfrm>
           <a:prstGeom prst="rect">
             <a:avLst/>
@@ -3315,10 +3346,10 @@
           </a:fontRef>
         </p:style>
         <p:txBody>
-          <a:bodyPr rtlCol="0" anchor="ctr"/>
-          <a:lstStyle/>
-          <a:p>
-            <a:pPr algn="l"/>
+          <a:bodyPr rtlCol="0" anchor="ctr" wrap="square" lIns="320040" tIns="164592"/>
+          <a:lstStyle/>
+          <a:p>
+            <a:pPr algn="ctr"/>
             <a:r>
               <a:rPr sz="2200" b="1">
                 <a:solidFill>
@@ -3326,21 +3357,45 @@
                 </a:solidFill>
                 <a:latin typeface="Calibri"/>
               </a:rPr>
-              <a:t>  Impacto esperado</a:t>
-            </a:r>
-          </a:p>
-        </p:txBody>
-      </p:sp>
-      <p:sp>
-        <p:nvSpPr>
-          <p:cNvPr id="3" name="TextBox 2"/>
+              <a:t>8. Validación temporal vs aleatoria</a:t>
+            </a:r>
+          </a:p>
+        </p:txBody>
+      </p:sp>
+      <p:pic>
+        <p:nvPicPr>
+          <p:cNvPr id="3" name="Picture 2" descr="11_comparison_pr_auc.png"/>
+          <p:cNvPicPr>
+            <a:picLocks noChangeAspect="1"/>
+          </p:cNvPicPr>
+          <p:nvPr/>
+        </p:nvPicPr>
+        <p:blipFill>
+          <a:blip r:embed="rId2"/>
+          <a:stretch>
+            <a:fillRect/>
+          </a:stretch>
+        </p:blipFill>
+        <p:spPr>
+          <a:xfrm>
+            <a:off x="320040" y="1051560"/>
+            <a:ext cx="6858000" cy="3570580"/>
+          </a:xfrm>
+          <a:prstGeom prst="rect">
+            <a:avLst/>
+          </a:prstGeom>
+        </p:spPr>
+      </p:pic>
+      <p:sp>
+        <p:nvSpPr>
+          <p:cNvPr id="4" name="TextBox 3"/>
           <p:cNvSpPr txBox="1"/>
           <p:nvPr/>
         </p:nvSpPr>
         <p:spPr>
           <a:xfrm>
-            <a:off x="731520" y="1280160"/>
-            <a:ext cx="10515600" cy="5029200"/>
+            <a:off x="7315200" y="1280160"/>
+            <a:ext cx="4389120" cy="4754880"/>
           </a:xfrm>
           <a:prstGeom prst="rect">
             <a:avLst/>
@@ -3348,102 +3403,118 @@
           <a:noFill/>
         </p:spPr>
         <p:txBody>
-          <a:bodyPr wrap="none">
+          <a:bodyPr wrap="square">
             <a:spAutoFit/>
           </a:bodyPr>
           <a:lstStyle/>
           <a:p>
             <a:pPr>
               <a:spcAft>
-                <a:spcPts val="600"/>
-              </a:spcAft>
-            </a:pPr>
-            <a:r>
-              <a:rPr sz="1700" b="0">
-                <a:solidFill>
-                  <a:srgbClr val="222222"/>
-                </a:solidFill>
-                <a:latin typeface="Calibri"/>
-              </a:rPr>
-              <a:t>Prioriza la cola de revisión humana (Top-100 / Top-500).</a:t>
-            </a:r>
-          </a:p>
-          <a:p>
-            <a:pPr>
-              <a:spcAft>
-                <a:spcPts val="600"/>
-              </a:spcAft>
-            </a:pPr>
-            <a:r>
-              <a:rPr sz="1700" b="0">
-                <a:solidFill>
-                  <a:srgbClr val="222222"/>
-                </a:solidFill>
-                <a:latin typeface="Calibri"/>
-              </a:rPr>
-              <a:t>Reduce fraudes no detectados vs reglas estáticas.</a:t>
-            </a:r>
-          </a:p>
-          <a:p>
-            <a:pPr>
-              <a:spcAft>
-                <a:spcPts val="600"/>
-              </a:spcAft>
-            </a:pPr>
-            <a:r>
-              <a:rPr sz="1700" b="0">
-                <a:solidFill>
-                  <a:srgbClr val="222222"/>
-                </a:solidFill>
-                <a:latin typeface="Calibri"/>
-              </a:rPr>
-              <a:t>Evita saturar al equipo con miles de falsas alarmas.</a:t>
-            </a:r>
-          </a:p>
-          <a:p>
-            <a:pPr>
-              <a:spcAft>
-                <a:spcPts val="600"/>
-              </a:spcAft>
-            </a:pPr>
-            <a:r>
-              <a:rPr sz="1700" b="0">
-                <a:solidFill>
-                  <a:srgbClr val="222222"/>
-                </a:solidFill>
-                <a:latin typeface="Calibri"/>
-              </a:rPr>
-              <a:t>Umbral = decisión de negocio explícita (Precision + capacidad).</a:t>
-            </a:r>
-          </a:p>
-          <a:p>
-            <a:pPr>
-              <a:spcAft>
-                <a:spcPts val="600"/>
-              </a:spcAft>
-            </a:pPr>
-            <a:r>
-              <a:rPr sz="1700" b="0">
-                <a:solidFill>
-                  <a:srgbClr val="222222"/>
-                </a:solidFill>
-                <a:latin typeface="Calibri"/>
-              </a:rPr>
-              <a:t>Escalable a scoring batch / near real-time.</a:t>
-            </a:r>
-          </a:p>
-        </p:txBody>
-      </p:sp>
-      <p:sp>
-        <p:nvSpPr>
-          <p:cNvPr id="4" name="TextBox 3"/>
+                <a:spcPts val="800"/>
+              </a:spcAft>
+            </a:pPr>
+            <a:r>
+              <a:rPr sz="1500" b="0">
+                <a:solidFill>
+                  <a:srgbClr val="222222"/>
+                </a:solidFill>
+                <a:latin typeface="Calibri"/>
+              </a:rPr>
+              <a:t>•  Aleatorio: mezcla pasado y futuro.</a:t>
+            </a:r>
+          </a:p>
+          <a:p>
+            <a:pPr>
+              <a:spcAft>
+                <a:spcPts val="800"/>
+              </a:spcAft>
+            </a:pPr>
+            <a:r>
+              <a:rPr sz="1500" b="0">
+                <a:solidFill>
+                  <a:srgbClr val="222222"/>
+                </a:solidFill>
+                <a:latin typeface="Calibri"/>
+              </a:rPr>
+              <a:t>•  Temporal: entrena con anteriores, prueba con posteriores (más realista).</a:t>
+            </a:r>
+          </a:p>
+          <a:p>
+            <a:pPr>
+              <a:spcAft>
+                <a:spcPts val="800"/>
+              </a:spcAft>
+            </a:pPr>
+            <a:r>
+              <a:rPr sz="1500" b="0">
+                <a:solidFill>
+                  <a:srgbClr val="222222"/>
+                </a:solidFill>
+                <a:latin typeface="Calibri"/>
+              </a:rPr>
+              <a:t>•  Mejor temporal: RandomForest</a:t>
+            </a:r>
+          </a:p>
+          <a:p>
+            <a:pPr>
+              <a:spcAft>
+                <a:spcPts val="800"/>
+              </a:spcAft>
+            </a:pPr>
+            <a:r>
+              <a:rPr sz="1500" b="0">
+                <a:solidFill>
+                  <a:srgbClr val="222222"/>
+                </a:solidFill>
+                <a:latin typeface="Calibri"/>
+              </a:rPr>
+              <a:t>•  PR-AUC 0.813</a:t>
+            </a:r>
+          </a:p>
+          <a:p>
+            <a:pPr>
+              <a:spcAft>
+                <a:spcPts val="800"/>
+              </a:spcAft>
+            </a:pPr>
+            <a:r>
+              <a:rPr sz="1500" b="0">
+                <a:solidFill>
+                  <a:srgbClr val="222222"/>
+                </a:solidFill>
+                <a:latin typeface="Calibri"/>
+              </a:rPr>
+              <a:t>•  Recall 73.0% · Precision 94.7%</a:t>
+            </a:r>
+          </a:p>
+          <a:p>
+            <a:pPr>
+              <a:spcAft>
+                <a:spcPts val="800"/>
+              </a:spcAft>
+            </a:pPr>
+            <a:r>
+              <a:rPr sz="1500" b="0">
+                <a:solidFill>
+                  <a:srgbClr val="222222"/>
+                </a:solidFill>
+                <a:latin typeface="Calibri"/>
+              </a:rPr>
+              <a:t>•  Top-100 → 59 · Top-500 → 65</a:t>
+            </a:r>
+          </a:p>
+        </p:txBody>
+      </p:sp>
+      <p:sp>
+        <p:nvSpPr>
+          <p:cNvPr id="5" name="TextBox 4"/>
           <p:cNvSpPr txBox="1"/>
           <p:nvPr/>
         </p:nvSpPr>
         <p:spPr>
           <a:xfrm>
-            <a:off x="365760" y="6492240"/>
-            <a:ext cx="11430000" cy="274320"/>
+            <a:off x="365760" y="6537960"/>
+            <a:ext cx="11430000" cy="256032"/>
           </a:xfrm>
           <a:prstGeom prst="rect">
             <a:avLst/>
@@ -3463,7 +3534,7 @@
                 </a:solidFill>
                 <a:latin typeface="Calibri"/>
               </a:rPr>
-              <a:t>Grupo 33 · Detección de Fraude · 10/12</a:t>
+              <a:t>Grupo 33 · Detección de Fraude en Tarjetas de Crédito · 10/12</a:t>
             </a:r>
           </a:p>
         </p:txBody>
@@ -3495,7 +3566,7 @@
         <p:spPr>
           <a:xfrm>
             <a:off x="0" y="0"/>
-            <a:ext cx="12191695" cy="822960"/>
+            <a:ext cx="12191695" cy="777240"/>
           </a:xfrm>
           <a:prstGeom prst="rect">
             <a:avLst/>
@@ -3522,10 +3593,10 @@
           </a:fontRef>
         </p:style>
         <p:txBody>
-          <a:bodyPr rtlCol="0" anchor="ctr"/>
-          <a:lstStyle/>
-          <a:p>
-            <a:pPr algn="l"/>
+          <a:bodyPr rtlCol="0" anchor="ctr" wrap="square" lIns="320040" tIns="164592"/>
+          <a:lstStyle/>
+          <a:p>
+            <a:pPr algn="ctr"/>
             <a:r>
               <a:rPr sz="2200" b="1">
                 <a:solidFill>
@@ -3533,7 +3604,7 @@
                 </a:solidFill>
                 <a:latin typeface="Calibri"/>
               </a:rPr>
-              <a:t>  Riesgos, limitaciones y ética</a:t>
+              <a:t>9. Impacto, riesgos y consideraciones éticas</a:t>
             </a:r>
           </a:p>
         </p:txBody>
@@ -3546,8 +3617,8 @@
         </p:nvSpPr>
         <p:spPr>
           <a:xfrm>
-            <a:off x="731520" y="1280160"/>
-            <a:ext cx="10515600" cy="5029200"/>
+            <a:off x="548640" y="1097280"/>
+            <a:ext cx="11064240" cy="5120640"/>
           </a:xfrm>
           <a:prstGeom prst="rect">
             <a:avLst/>
@@ -3555,88 +3626,104 @@
           <a:noFill/>
         </p:spPr>
         <p:txBody>
-          <a:bodyPr wrap="none">
+          <a:bodyPr wrap="square">
             <a:spAutoFit/>
           </a:bodyPr>
           <a:lstStyle/>
           <a:p>
             <a:pPr>
               <a:spcAft>
-                <a:spcPts val="600"/>
-              </a:spcAft>
-            </a:pPr>
-            <a:r>
-              <a:rPr sz="1700" b="0">
-                <a:solidFill>
-                  <a:srgbClr val="222222"/>
-                </a:solidFill>
-                <a:latin typeface="Calibri"/>
-              </a:rPr>
-              <a:t>Dataset de solo 2 días (2013): representatividad limitada.</a:t>
-            </a:r>
-          </a:p>
-          <a:p>
-            <a:pPr>
-              <a:spcAft>
-                <a:spcPts val="600"/>
-              </a:spcAft>
-            </a:pPr>
-            <a:r>
-              <a:rPr sz="1700" b="0">
-                <a:solidFill>
-                  <a:srgbClr val="222222"/>
-                </a:solidFill>
-                <a:latin typeface="Calibri"/>
-              </a:rPr>
-              <a:t>Variables PCA dificultan explicación regulatoria.</a:t>
-            </a:r>
-          </a:p>
-          <a:p>
-            <a:pPr>
-              <a:spcAft>
-                <a:spcPts val="600"/>
-              </a:spcAft>
-            </a:pPr>
-            <a:r>
-              <a:rPr sz="1700" b="0">
-                <a:solidFill>
-                  <a:srgbClr val="222222"/>
-                </a:solidFill>
-                <a:latin typeface="Calibri"/>
-              </a:rPr>
-              <a:t>Falso positivo = fricción al cliente; falso negativo = pérdida.</a:t>
-            </a:r>
-          </a:p>
-          <a:p>
-            <a:pPr>
-              <a:spcAft>
-                <a:spcPts val="600"/>
-              </a:spcAft>
-            </a:pPr>
-            <a:r>
-              <a:rPr sz="1700" b="0">
-                <a:solidFill>
-                  <a:srgbClr val="222222"/>
-                </a:solidFill>
-                <a:latin typeface="Calibri"/>
-              </a:rPr>
-              <a:t>Datos anonimizados; sin PII; licencia ODbL.</a:t>
-            </a:r>
-          </a:p>
-          <a:p>
-            <a:pPr>
-              <a:spcAft>
-                <a:spcPts val="600"/>
-              </a:spcAft>
-            </a:pPr>
-            <a:r>
-              <a:rPr sz="1700" b="0">
-                <a:solidFill>
-                  <a:srgbClr val="222222"/>
-                </a:solidFill>
-                <a:latin typeface="Calibri"/>
-              </a:rPr>
-              <a:t>Requiere monitoreo de drift y recalibración del umbral.</a:t>
+                <a:spcPts val="800"/>
+              </a:spcAft>
+            </a:pPr>
+            <a:r>
+              <a:rPr sz="1600" b="0">
+                <a:solidFill>
+                  <a:srgbClr val="222222"/>
+                </a:solidFill>
+                <a:latin typeface="Calibri"/>
+              </a:rPr>
+              <a:t>•  Impacto: prioriza la cola de revisión; reduce fraudes no detectados y el ruido operativo.</a:t>
+            </a:r>
+          </a:p>
+          <a:p>
+            <a:pPr>
+              <a:spcAft>
+                <a:spcPts val="800"/>
+              </a:spcAft>
+            </a:pPr>
+            <a:r>
+              <a:rPr sz="1600" b="0">
+                <a:solidFill>
+                  <a:srgbClr val="222222"/>
+                </a:solidFill>
+                <a:latin typeface="Calibri"/>
+              </a:rPr>
+              <a:t>•  Combinable con reglas existentes (ML como capa de priorización).</a:t>
+            </a:r>
+          </a:p>
+          <a:p>
+            <a:pPr>
+              <a:spcAft>
+                <a:spcPts val="800"/>
+              </a:spcAft>
+            </a:pPr>
+            <a:r>
+              <a:rPr sz="1600" b="0">
+                <a:solidFill>
+                  <a:srgbClr val="222222"/>
+                </a:solidFill>
+                <a:latin typeface="Calibri"/>
+              </a:rPr>
+              <a:t>•  Riesgos: dataset de 2 días (2013); PCA poco interpretable; posible drift.</a:t>
+            </a:r>
+          </a:p>
+          <a:p>
+            <a:pPr>
+              <a:spcAft>
+                <a:spcPts val="800"/>
+              </a:spcAft>
+            </a:pPr>
+            <a:r>
+              <a:rPr sz="1600" b="0">
+                <a:solidFill>
+                  <a:srgbClr val="222222"/>
+                </a:solidFill>
+                <a:latin typeface="Calibri"/>
+              </a:rPr>
+              <a:t>•  Ética: datos anonimizados (sin PII); falso positivo = fricción al cliente; falso negativo = pérdida financiera.</a:t>
+            </a:r>
+          </a:p>
+          <a:p>
+            <a:pPr>
+              <a:spcAft>
+                <a:spcPts val="800"/>
+              </a:spcAft>
+            </a:pPr>
+            <a:r>
+              <a:rPr sz="1600" b="0">
+                <a:solidFill>
+                  <a:srgbClr val="222222"/>
+                </a:solidFill>
+                <a:latin typeface="Calibri"/>
+              </a:rPr>
+              <a:t>•  El umbral es una decisión de negocio explícita, no un default técnico.</a:t>
+            </a:r>
+          </a:p>
+          <a:p>
+            <a:pPr>
+              <a:spcAft>
+                <a:spcPts val="800"/>
+              </a:spcAft>
+            </a:pPr>
+            <a:r>
+              <a:rPr sz="1600" b="0">
+                <a:solidFill>
+                  <a:srgbClr val="222222"/>
+                </a:solidFill>
+                <a:latin typeface="Calibri"/>
+              </a:rPr>
+              <a:t>•  Uso académico bajo licencia ODbL; despliegue real requiere supervisión humana.</a:t>
             </a:r>
           </a:p>
         </p:txBody>
@@ -3649,8 +3736,8 @@
         </p:nvSpPr>
         <p:spPr>
           <a:xfrm>
-            <a:off x="365760" y="6492240"/>
-            <a:ext cx="11430000" cy="274320"/>
+            <a:off x="365760" y="6537960"/>
+            <a:ext cx="11430000" cy="256032"/>
           </a:xfrm>
           <a:prstGeom prst="rect">
             <a:avLst/>
@@ -3670,7 +3757,7 @@
                 </a:solidFill>
                 <a:latin typeface="Calibri"/>
               </a:rPr>
-              <a:t>Grupo 33 · Detección de Fraude · 11/12</a:t>
+              <a:t>Grupo 33 · Detección de Fraude en Tarjetas de Crédito · 11/12</a:t>
             </a:r>
           </a:p>
         </p:txBody>
@@ -3702,7 +3789,7 @@
         <p:spPr>
           <a:xfrm>
             <a:off x="0" y="0"/>
-            <a:ext cx="12191695" cy="822960"/>
+            <a:ext cx="12191695" cy="777240"/>
           </a:xfrm>
           <a:prstGeom prst="rect">
             <a:avLst/>
@@ -3729,10 +3816,10 @@
           </a:fontRef>
         </p:style>
         <p:txBody>
-          <a:bodyPr rtlCol="0" anchor="ctr"/>
-          <a:lstStyle/>
-          <a:p>
-            <a:pPr algn="l"/>
+          <a:bodyPr rtlCol="0" anchor="ctr" wrap="square" lIns="320040" tIns="164592"/>
+          <a:lstStyle/>
+          <a:p>
+            <a:pPr algn="ctr"/>
             <a:r>
               <a:rPr sz="2200" b="1">
                 <a:solidFill>
@@ -3740,7 +3827,7 @@
                 </a:solidFill>
                 <a:latin typeface="Calibri"/>
               </a:rPr>
-              <a:t>  Conclusiones y próximos pasos</a:t>
+              <a:t>10. Conclusiones y recomendaciones</a:t>
             </a:r>
           </a:p>
         </p:txBody>
@@ -3753,8 +3840,8 @@
         </p:nvSpPr>
         <p:spPr>
           <a:xfrm>
-            <a:off x="731520" y="1280160"/>
-            <a:ext cx="10515600" cy="5029200"/>
+            <a:off x="548640" y="1097280"/>
+            <a:ext cx="11064240" cy="5120640"/>
           </a:xfrm>
           <a:prstGeom prst="rect">
             <a:avLst/>
@@ -3762,14 +3849,14 @@
           <a:noFill/>
         </p:spPr>
         <p:txBody>
-          <a:bodyPr wrap="none">
+          <a:bodyPr wrap="square">
             <a:spAutoFit/>
           </a:bodyPr>
           <a:lstStyle/>
           <a:p>
             <a:pPr>
               <a:spcAft>
-                <a:spcPts val="600"/>
+                <a:spcPts val="800"/>
               </a:spcAft>
             </a:pPr>
             <a:r>
@@ -3779,13 +3866,13 @@
                 </a:solidFill>
                 <a:latin typeface="Calibri"/>
               </a:rPr>
-              <a:t>Modelo recomendado: XGBoost (mejor PR-AUC).</a:t>
-            </a:r>
-          </a:p>
-          <a:p>
-            <a:pPr>
-              <a:spcAft>
-                <a:spcPts val="600"/>
+              <a:t>•  Recomendamos XGBoost como modelo candidato (mejor PR-AUC en holdout aleatorio).</a:t>
+            </a:r>
+          </a:p>
+          <a:p>
+            <a:pPr>
+              <a:spcAft>
+                <a:spcPts val="800"/>
               </a:spcAft>
             </a:pPr>
             <a:r>
@@ -3795,13 +3882,13 @@
                 </a:solidFill>
                 <a:latin typeface="Calibri"/>
               </a:rPr>
-              <a:t>KPI técnicos: PR-AUC · Recall · Precision.</a:t>
-            </a:r>
-          </a:p>
-          <a:p>
-            <a:pPr>
-              <a:spcAft>
-                <a:spcPts val="600"/>
+              <a:t>•  Reportar siempre PR-AUC, Recall, Precision y cantidad de alertas.</a:t>
+            </a:r>
+          </a:p>
+          <a:p>
+            <a:pPr>
+              <a:spcAft>
+                <a:spcPts val="800"/>
               </a:spcAft>
             </a:pPr>
             <a:r>
@@ -3811,13 +3898,13 @@
                 </a:solidFill>
                 <a:latin typeface="Calibri"/>
               </a:rPr>
-              <a:t>KPI de negocio: captura Top-100 / Top-500 y alertas revisables.</a:t>
-            </a:r>
-          </a:p>
-          <a:p>
-            <a:pPr>
-              <a:spcAft>
-                <a:spcPts val="600"/>
+              <a:t>•  Usar captura Top-100 / Top-500 como KPI operativo de la cola de revisión.</a:t>
+            </a:r>
+          </a:p>
+          <a:p>
+            <a:pPr>
+              <a:spcAft>
+                <a:spcPts val="800"/>
               </a:spcAft>
             </a:pPr>
             <a:r>
@@ -3827,13 +3914,13 @@
                 </a:solidFill>
                 <a:latin typeface="Calibri"/>
               </a:rPr>
-              <a:t>Validar siempre con esquema temporal antes de producción.</a:t>
-            </a:r>
-          </a:p>
-          <a:p>
-            <a:pPr>
-              <a:spcAft>
-                <a:spcPts val="600"/>
+              <a:t>•  Validar con esquema temporal antes de cualquier despliegue.</a:t>
+            </a:r>
+          </a:p>
+          <a:p>
+            <a:pPr>
+              <a:spcAft>
+                <a:spcPts val="800"/>
               </a:spcAft>
             </a:pPr>
             <a:r>
@@ -3843,13 +3930,13 @@
                 </a:solidFill>
                 <a:latin typeface="Calibri"/>
               </a:rPr>
-              <a:t>Próximos pasos: feedback del analista, drift monitoring, features adicionales.</a:t>
-            </a:r>
-          </a:p>
-          <a:p>
-            <a:pPr>
-              <a:spcAft>
-                <a:spcPts val="600"/>
+              <a:t>•  Próximos pasos: feedback del analista, monitoreo de drift, features adicionales (dispositivo, geo, historial) y calibración de scores.</a:t>
+            </a:r>
+          </a:p>
+          <a:p>
+            <a:pPr>
+              <a:spcAft>
+                <a:spcPts val="800"/>
               </a:spcAft>
             </a:pPr>
             <a:r>
@@ -3859,7 +3946,7 @@
                 </a:solidFill>
                 <a:latin typeface="Calibri"/>
               </a:rPr>
-              <a:t>Código + informe + esta presentación en el repositorio del Grupo 33.</a:t>
+              <a:t>•  Código reproducible en el repositorio GitHub del Grupo 33 (README + notebook).</a:t>
             </a:r>
           </a:p>
         </p:txBody>
@@ -3872,8 +3959,8 @@
         </p:nvSpPr>
         <p:spPr>
           <a:xfrm>
-            <a:off x="365760" y="6492240"/>
-            <a:ext cx="11430000" cy="274320"/>
+            <a:off x="365760" y="6537960"/>
+            <a:ext cx="11430000" cy="256032"/>
           </a:xfrm>
           <a:prstGeom prst="rect">
             <a:avLst/>
@@ -3893,7 +3980,7 @@
                 </a:solidFill>
                 <a:latin typeface="Calibri"/>
               </a:rPr>
-              <a:t>Grupo 33 · Detección de Fraude · 12/12</a:t>
+              <a:t>Grupo 33 · Detección de Fraude en Tarjetas de Crédito · 12/12</a:t>
             </a:r>
           </a:p>
         </p:txBody>
@@ -3925,7 +4012,7 @@
         <p:spPr>
           <a:xfrm>
             <a:off x="0" y="0"/>
-            <a:ext cx="12191695" cy="822960"/>
+            <a:ext cx="12191695" cy="777240"/>
           </a:xfrm>
           <a:prstGeom prst="rect">
             <a:avLst/>
@@ -3952,10 +4039,10 @@
           </a:fontRef>
         </p:style>
         <p:txBody>
-          <a:bodyPr rtlCol="0" anchor="ctr"/>
-          <a:lstStyle/>
-          <a:p>
-            <a:pPr algn="l"/>
+          <a:bodyPr rtlCol="0" anchor="ctr" wrap="square" lIns="320040" tIns="164592"/>
+          <a:lstStyle/>
+          <a:p>
+            <a:pPr algn="ctr"/>
             <a:r>
               <a:rPr sz="2200" b="1">
                 <a:solidFill>
@@ -3963,7 +4050,7 @@
                 </a:solidFill>
                 <a:latin typeface="Calibri"/>
               </a:rPr>
-              <a:t>  Agenda</a:t>
+              <a:t>Índice</a:t>
             </a:r>
           </a:p>
         </p:txBody>
@@ -3976,8 +4063,8 @@
         </p:nvSpPr>
         <p:spPr>
           <a:xfrm>
-            <a:off x="914400" y="1280160"/>
-            <a:ext cx="10058400" cy="4572000"/>
+            <a:off x="1097280" y="1188720"/>
+            <a:ext cx="9601200" cy="5029200"/>
           </a:xfrm>
           <a:prstGeom prst="rect">
             <a:avLst/>
@@ -3985,14 +4072,14 @@
           <a:noFill/>
         </p:spPr>
         <p:txBody>
-          <a:bodyPr wrap="none">
+          <a:bodyPr wrap="square">
             <a:spAutoFit/>
           </a:bodyPr>
           <a:lstStyle/>
           <a:p>
             <a:pPr>
               <a:spcAft>
-                <a:spcPts val="600"/>
+                <a:spcPts val="800"/>
               </a:spcAft>
             </a:pPr>
             <a:r>
@@ -4002,13 +4089,13 @@
                 </a:solidFill>
                 <a:latin typeface="Calibri"/>
               </a:rPr>
-              <a:t>1. Problema de negocio y objetivo</a:t>
-            </a:r>
-          </a:p>
-          <a:p>
-            <a:pPr>
-              <a:spcAft>
-                <a:spcPts val="600"/>
+              <a:t>•  1. Resumen ejecutivo</a:t>
+            </a:r>
+          </a:p>
+          <a:p>
+            <a:pPr>
+              <a:spcAft>
+                <a:spcPts val="800"/>
               </a:spcAft>
             </a:pPr>
             <a:r>
@@ -4018,13 +4105,13 @@
                 </a:solidFill>
                 <a:latin typeface="Calibri"/>
               </a:rPr>
-              <a:t>2. Datos y desbalance extremo</a:t>
-            </a:r>
-          </a:p>
-          <a:p>
-            <a:pPr>
-              <a:spcAft>
-                <a:spcPts val="600"/>
+              <a:t>•  2. Problema de negocio y objetivo</a:t>
+            </a:r>
+          </a:p>
+          <a:p>
+            <a:pPr>
+              <a:spcAft>
+                <a:spcPts val="800"/>
               </a:spcAft>
             </a:pPr>
             <a:r>
@@ -4034,13 +4121,13 @@
                 </a:solidFill>
                 <a:latin typeface="Calibri"/>
               </a:rPr>
-              <a:t>3. Metodología CRISP-DM</a:t>
-            </a:r>
-          </a:p>
-          <a:p>
-            <a:pPr>
-              <a:spcAft>
-                <a:spcPts val="600"/>
+              <a:t>•  3. Datos y metodología (CRISP-DM)</a:t>
+            </a:r>
+          </a:p>
+          <a:p>
+            <a:pPr>
+              <a:spcAft>
+                <a:spcPts val="800"/>
               </a:spcAft>
             </a:pPr>
             <a:r>
@@ -4050,13 +4137,13 @@
                 </a:solidFill>
                 <a:latin typeface="Calibri"/>
               </a:rPr>
-              <a:t>4. Modelos y métricas principales (PR-AUC, Recall, Precision)</a:t>
-            </a:r>
-          </a:p>
-          <a:p>
-            <a:pPr>
-              <a:spcAft>
-                <a:spcPts val="600"/>
+              <a:t>•  4. Modelos evaluados y selección</a:t>
+            </a:r>
+          </a:p>
+          <a:p>
+            <a:pPr>
+              <a:spcAft>
+                <a:spcPts val="800"/>
               </a:spcAft>
             </a:pPr>
             <a:r>
@@ -4066,13 +4153,13 @@
                 </a:solidFill>
                 <a:latin typeface="Calibri"/>
               </a:rPr>
-              <a:t>5. Métrica de negocio: captura Top-100 / Top-500</a:t>
-            </a:r>
-          </a:p>
-          <a:p>
-            <a:pPr>
-              <a:spcAft>
-                <a:spcPts val="600"/>
+              <a:t>•  5. Resultados clave (PR-AUC, Recall, Precision)</a:t>
+            </a:r>
+          </a:p>
+          <a:p>
+            <a:pPr>
+              <a:spcAft>
+                <a:spcPts val="800"/>
               </a:spcAft>
             </a:pPr>
             <a:r>
@@ -4082,13 +4169,13 @@
                 </a:solidFill>
                 <a:latin typeface="Calibri"/>
               </a:rPr>
-              <a:t>6. Validación temporal vs aleatoria</a:t>
-            </a:r>
-          </a:p>
-          <a:p>
-            <a:pPr>
-              <a:spcAft>
-                <a:spcPts val="600"/>
+              <a:t>•  6. Métrica de negocio: captura Top-100 / Top-500</a:t>
+            </a:r>
+          </a:p>
+          <a:p>
+            <a:pPr>
+              <a:spcAft>
+                <a:spcPts val="800"/>
               </a:spcAft>
             </a:pPr>
             <a:r>
@@ -4098,7 +4185,55 @@
                 </a:solidFill>
                 <a:latin typeface="Calibri"/>
               </a:rPr>
-              <a:t>7. Impacto, riesgos y recomendaciones</a:t>
+              <a:t>•  7. Umbral operativo y carga de revisión</a:t>
+            </a:r>
+          </a:p>
+          <a:p>
+            <a:pPr>
+              <a:spcAft>
+                <a:spcPts val="800"/>
+              </a:spcAft>
+            </a:pPr>
+            <a:r>
+              <a:rPr sz="1800" b="0">
+                <a:solidFill>
+                  <a:srgbClr val="222222"/>
+                </a:solidFill>
+                <a:latin typeface="Calibri"/>
+              </a:rPr>
+              <a:t>•  8. Validación temporal vs aleatoria</a:t>
+            </a:r>
+          </a:p>
+          <a:p>
+            <a:pPr>
+              <a:spcAft>
+                <a:spcPts val="800"/>
+              </a:spcAft>
+            </a:pPr>
+            <a:r>
+              <a:rPr sz="1800" b="0">
+                <a:solidFill>
+                  <a:srgbClr val="222222"/>
+                </a:solidFill>
+                <a:latin typeface="Calibri"/>
+              </a:rPr>
+              <a:t>•  9. Impacto, riesgos y ética</a:t>
+            </a:r>
+          </a:p>
+          <a:p>
+            <a:pPr>
+              <a:spcAft>
+                <a:spcPts val="800"/>
+              </a:spcAft>
+            </a:pPr>
+            <a:r>
+              <a:rPr sz="1800" b="0">
+                <a:solidFill>
+                  <a:srgbClr val="222222"/>
+                </a:solidFill>
+                <a:latin typeface="Calibri"/>
+              </a:rPr>
+              <a:t>•  10. Conclusiones y recomendaciones</a:t>
             </a:r>
           </a:p>
         </p:txBody>
@@ -4111,8 +4246,8 @@
         </p:nvSpPr>
         <p:spPr>
           <a:xfrm>
-            <a:off x="365760" y="6492240"/>
-            <a:ext cx="11430000" cy="274320"/>
+            <a:off x="365760" y="6537960"/>
+            <a:ext cx="11430000" cy="256032"/>
           </a:xfrm>
           <a:prstGeom prst="rect">
             <a:avLst/>
@@ -4132,7 +4267,7 @@
                 </a:solidFill>
                 <a:latin typeface="Calibri"/>
               </a:rPr>
-              <a:t>Grupo 33 · Detección de Fraude · 2/12</a:t>
+              <a:t>Grupo 33 · Detección de Fraude en Tarjetas de Crédito · 2/12</a:t>
             </a:r>
           </a:p>
         </p:txBody>
@@ -4164,7 +4299,7 @@
         <p:spPr>
           <a:xfrm>
             <a:off x="0" y="0"/>
-            <a:ext cx="12191695" cy="822960"/>
+            <a:ext cx="12191695" cy="777240"/>
           </a:xfrm>
           <a:prstGeom prst="rect">
             <a:avLst/>
@@ -4191,10 +4326,10 @@
           </a:fontRef>
         </p:style>
         <p:txBody>
-          <a:bodyPr rtlCol="0" anchor="ctr"/>
-          <a:lstStyle/>
-          <a:p>
-            <a:pPr algn="l"/>
+          <a:bodyPr rtlCol="0" anchor="ctr" wrap="square" lIns="320040" tIns="164592"/>
+          <a:lstStyle/>
+          <a:p>
+            <a:pPr algn="ctr"/>
             <a:r>
               <a:rPr sz="2200" b="1">
                 <a:solidFill>
@@ -4202,7 +4337,7 @@
                 </a:solidFill>
                 <a:latin typeface="Calibri"/>
               </a:rPr>
-              <a:t>  El problema: fraude con pocos casos y muchas operaciones</a:t>
+              <a:t>1. Resumen ejecutivo</a:t>
             </a:r>
           </a:p>
         </p:txBody>
@@ -4215,8 +4350,8 @@
         </p:nvSpPr>
         <p:spPr>
           <a:xfrm>
-            <a:off x="640080" y="1188720"/>
-            <a:ext cx="10972800" cy="5029200"/>
+            <a:off x="548640" y="1051560"/>
+            <a:ext cx="11064240" cy="5120640"/>
           </a:xfrm>
           <a:prstGeom prst="rect">
             <a:avLst/>
@@ -4224,14 +4359,14 @@
           <a:noFill/>
         </p:spPr>
         <p:txBody>
-          <a:bodyPr wrap="none">
+          <a:bodyPr wrap="square">
             <a:spAutoFit/>
           </a:bodyPr>
           <a:lstStyle/>
           <a:p>
             <a:pPr>
               <a:spcAft>
-                <a:spcPts val="600"/>
+                <a:spcPts val="800"/>
               </a:spcAft>
             </a:pPr>
             <a:r>
@@ -4241,13 +4376,13 @@
                 </a:solidFill>
                 <a:latin typeface="Calibri"/>
               </a:rPr>
-              <a:t>Pérdidas globales &gt; USD 33.000 M / año por fraude en tarjetas.</a:t>
-            </a:r>
-          </a:p>
-          <a:p>
-            <a:pPr>
-              <a:spcAft>
-                <a:spcPts val="600"/>
+              <a:t>•  Problema: detectar fraude en un flujo con desbalance extremo (492 fraudes en 284.807 transacciones; 0,172 %).</a:t>
+            </a:r>
+          </a:p>
+          <a:p>
+            <a:pPr>
+              <a:spcAft>
+                <a:spcPts val="800"/>
               </a:spcAft>
             </a:pPr>
             <a:r>
@@ -4257,13 +4392,13 @@
                 </a:solidFill>
                 <a:latin typeface="Calibri"/>
               </a:rPr>
-              <a:t>Dataset ULB: 283,726 transacciones · solo 473 fraudes (0.167%).</a:t>
-            </a:r>
-          </a:p>
-          <a:p>
-            <a:pPr>
-              <a:spcAft>
-                <a:spcPts val="600"/>
+              <a:t>•  Solución: modelo supervisado XGBoost que prioriza una cola de revisión humana.</a:t>
+            </a:r>
+          </a:p>
+          <a:p>
+            <a:pPr>
+              <a:spcAft>
+                <a:spcPts val="800"/>
               </a:spcAft>
             </a:pPr>
             <a:r>
@@ -4273,13 +4408,13 @@
                 </a:solidFill>
                 <a:latin typeface="Calibri"/>
               </a:rPr>
-              <a:t>Audiencia: Prevención de Fraude / Riesgo Crediticio.</a:t>
-            </a:r>
-          </a:p>
-          <a:p>
-            <a:pPr>
-              <a:spcAft>
-                <a:spcPts val="600"/>
+              <a:t>•  Resultados clave (holdout aleatorio): PR-AUC 0.827 · Recall 81.1% · Precision 86.5%.</a:t>
+            </a:r>
+          </a:p>
+          <a:p>
+            <a:pPr>
+              <a:spcAft>
+                <a:spcPts val="800"/>
               </a:spcAft>
             </a:pPr>
             <a:r>
@@ -4289,13 +4424,13 @@
                 </a:solidFill>
                 <a:latin typeface="Calibri"/>
               </a:rPr>
-              <a:t>Objetivo: maximizar detección SIN saturar al equipo con falsas alertas.</a:t>
-            </a:r>
-          </a:p>
-          <a:p>
-            <a:pPr>
-              <a:spcAft>
-                <a:spcPts val="600"/>
+              <a:t>•  Negocio: Top-100 → 77 fraudes; Top-500 → 82 fraudes (lift 98.0×).</a:t>
+            </a:r>
+          </a:p>
+          <a:p>
+            <a:pPr>
+              <a:spcAft>
+                <a:spcPts val="800"/>
               </a:spcAft>
             </a:pPr>
             <a:r>
@@ -4305,7 +4440,23 @@
                 </a:solidFill>
                 <a:latin typeface="Calibri"/>
               </a:rPr>
-              <a:t>Hipótesis: ML supera reglas estáticas priorizando una cola de revisión accionable.</a:t>
+              <a:t>•  Operación: umbral 0.55 → solo 88 alertas (77 TP / 11 FP), frente a miles con un FPR del 5 %.</a:t>
+            </a:r>
+          </a:p>
+          <a:p>
+            <a:pPr>
+              <a:spcAft>
+                <a:spcPts val="800"/>
+              </a:spcAft>
+            </a:pPr>
+            <a:r>
+              <a:rPr sz="1700" b="0">
+                <a:solidFill>
+                  <a:srgbClr val="222222"/>
+                </a:solidFill>
+                <a:latin typeface="Calibri"/>
+              </a:rPr>
+              <a:t>•  Robustez: en validación temporal, RandomForest alcanza PR-AUC 0.813.</a:t>
             </a:r>
           </a:p>
         </p:txBody>
@@ -4318,8 +4469,8 @@
         </p:nvSpPr>
         <p:spPr>
           <a:xfrm>
-            <a:off x="365760" y="6492240"/>
-            <a:ext cx="11430000" cy="274320"/>
+            <a:off x="365760" y="6537960"/>
+            <a:ext cx="11430000" cy="256032"/>
           </a:xfrm>
           <a:prstGeom prst="rect">
             <a:avLst/>
@@ -4339,7 +4490,7 @@
                 </a:solidFill>
                 <a:latin typeface="Calibri"/>
               </a:rPr>
-              <a:t>Grupo 33 · Detección de Fraude · 3/12</a:t>
+              <a:t>Grupo 33 · Detección de Fraude en Tarjetas de Crédito · 3/12</a:t>
             </a:r>
           </a:p>
         </p:txBody>
@@ -4371,7 +4522,7 @@
         <p:spPr>
           <a:xfrm>
             <a:off x="0" y="0"/>
-            <a:ext cx="12191695" cy="822960"/>
+            <a:ext cx="12191695" cy="777240"/>
           </a:xfrm>
           <a:prstGeom prst="rect">
             <a:avLst/>
@@ -4398,10 +4549,10 @@
           </a:fontRef>
         </p:style>
         <p:txBody>
-          <a:bodyPr rtlCol="0" anchor="ctr"/>
-          <a:lstStyle/>
-          <a:p>
-            <a:pPr algn="l"/>
+          <a:bodyPr rtlCol="0" anchor="ctr" wrap="square" lIns="320040" tIns="164592"/>
+          <a:lstStyle/>
+          <a:p>
+            <a:pPr algn="ctr"/>
             <a:r>
               <a:rPr sz="2200" b="1">
                 <a:solidFill>
@@ -4409,45 +4560,21 @@
                 </a:solidFill>
                 <a:latin typeface="Calibri"/>
               </a:rPr>
-              <a:t>  Datos: desbalance extremo</a:t>
-            </a:r>
-          </a:p>
-        </p:txBody>
-      </p:sp>
-      <p:pic>
-        <p:nvPicPr>
-          <p:cNvPr id="3" name="Picture 2" descr="01_class_distribution.png"/>
-          <p:cNvPicPr>
-            <a:picLocks noChangeAspect="1"/>
-          </p:cNvPicPr>
-          <p:nvPr/>
-        </p:nvPicPr>
-        <p:blipFill>
-          <a:blip r:embed="rId2"/>
-          <a:stretch>
-            <a:fillRect/>
-          </a:stretch>
-        </p:blipFill>
-        <p:spPr>
-          <a:xfrm>
-            <a:off x="548640" y="1097280"/>
-            <a:ext cx="5669280" cy="3002029"/>
-          </a:xfrm>
-          <a:prstGeom prst="rect">
-            <a:avLst/>
-          </a:prstGeom>
-        </p:spPr>
-      </p:pic>
-      <p:sp>
-        <p:nvSpPr>
-          <p:cNvPr id="4" name="TextBox 3"/>
+              <a:t>2. Problema de negocio y objetivo</a:t>
+            </a:r>
+          </a:p>
+        </p:txBody>
+      </p:sp>
+      <p:sp>
+        <p:nvSpPr>
+          <p:cNvPr id="3" name="TextBox 2"/>
           <p:cNvSpPr txBox="1"/>
           <p:nvPr/>
         </p:nvSpPr>
         <p:spPr>
           <a:xfrm>
-            <a:off x="6583680" y="1371600"/>
-            <a:ext cx="5029200" cy="4572000"/>
+            <a:off x="548640" y="1097280"/>
+            <a:ext cx="11064240" cy="5029200"/>
           </a:xfrm>
           <a:prstGeom prst="rect">
             <a:avLst/>
@@ -4455,118 +4582,118 @@
           <a:noFill/>
         </p:spPr>
         <p:txBody>
-          <a:bodyPr wrap="none">
+          <a:bodyPr wrap="square">
             <a:spAutoFit/>
           </a:bodyPr>
           <a:lstStyle/>
           <a:p>
             <a:pPr>
               <a:spcAft>
-                <a:spcPts val="600"/>
-              </a:spcAft>
-            </a:pPr>
-            <a:r>
-              <a:rPr sz="1600" b="0">
-                <a:solidFill>
-                  <a:srgbClr val="222222"/>
-                </a:solidFill>
-                <a:latin typeface="Calibri"/>
-              </a:rPr>
-              <a:t>473 fraudes vs 283,253 legítimas.</a:t>
-            </a:r>
-          </a:p>
-          <a:p>
-            <a:pPr>
-              <a:spcAft>
-                <a:spcPts val="600"/>
-              </a:spcAft>
-            </a:pPr>
-            <a:r>
-              <a:rPr sz="1600" b="0">
-                <a:solidFill>
-                  <a:srgbClr val="222222"/>
-                </a:solidFill>
-                <a:latin typeface="Calibri"/>
-              </a:rPr>
-              <a:t>Sin nulos; duplicados eliminados.</a:t>
-            </a:r>
-          </a:p>
-          <a:p>
-            <a:pPr>
-              <a:spcAft>
-                <a:spcPts val="600"/>
-              </a:spcAft>
-            </a:pPr>
-            <a:r>
-              <a:rPr sz="1600" b="0">
-                <a:solidFill>
-                  <a:srgbClr val="222222"/>
-                </a:solidFill>
-                <a:latin typeface="Calibri"/>
-              </a:rPr>
-              <a:t>V1–V28 = PCA anonimizado.</a:t>
-            </a:r>
-          </a:p>
-          <a:p>
-            <a:pPr>
-              <a:spcAft>
-                <a:spcPts val="600"/>
-              </a:spcAft>
-            </a:pPr>
-            <a:r>
-              <a:rPr sz="1600" b="0">
-                <a:solidFill>
-                  <a:srgbClr val="222222"/>
-                </a:solidFill>
-                <a:latin typeface="Calibri"/>
-              </a:rPr>
-              <a:t>Amount sesgado → log1p.</a:t>
-            </a:r>
-          </a:p>
-          <a:p>
-            <a:pPr>
-              <a:spcAft>
-                <a:spcPts val="600"/>
-              </a:spcAft>
-            </a:pPr>
-            <a:r>
-              <a:rPr sz="1600" b="0">
-                <a:solidFill>
-                  <a:srgbClr val="222222"/>
-                </a:solidFill>
-                <a:latin typeface="Calibri"/>
-              </a:rPr>
-              <a:t>Time habilita validación temporal.</a:t>
-            </a:r>
-          </a:p>
-          <a:p>
-            <a:pPr>
-              <a:spcAft>
-                <a:spcPts val="600"/>
-              </a:spcAft>
-            </a:pPr>
-            <a:r>
-              <a:rPr sz="1600" b="0">
-                <a:solidFill>
-                  <a:srgbClr val="222222"/>
-                </a:solidFill>
-                <a:latin typeface="Calibri"/>
-              </a:rPr>
-              <a:t>Accuracy engaña → usamos PR-AUC.</a:t>
-            </a:r>
-          </a:p>
-        </p:txBody>
-      </p:sp>
-      <p:sp>
-        <p:nvSpPr>
-          <p:cNvPr id="5" name="TextBox 4"/>
+                <a:spcPts val="800"/>
+              </a:spcAft>
+            </a:pPr>
+            <a:r>
+              <a:rPr sz="1700" b="0">
+                <a:solidFill>
+                  <a:srgbClr val="222222"/>
+                </a:solidFill>
+                <a:latin typeface="Calibri"/>
+              </a:rPr>
+              <a:t>•  Audiencia: Prevención de Fraude / Gestión de Riesgo Crediticio.</a:t>
+            </a:r>
+          </a:p>
+          <a:p>
+            <a:pPr>
+              <a:spcAft>
+                <a:spcPts val="800"/>
+              </a:spcAft>
+            </a:pPr>
+            <a:r>
+              <a:rPr sz="1700" b="0">
+                <a:solidFill>
+                  <a:srgbClr val="222222"/>
+                </a:solidFill>
+                <a:latin typeface="Calibri"/>
+              </a:rPr>
+              <a:t>•  Objetivo medible: clasificar cada transacción (fraude vs legítima) maximizando detección y controlando alertas revisables.</a:t>
+            </a:r>
+          </a:p>
+          <a:p>
+            <a:pPr>
+              <a:spcAft>
+                <a:spcPts val="800"/>
+              </a:spcAft>
+            </a:pPr>
+            <a:r>
+              <a:rPr sz="1700" b="0">
+                <a:solidFill>
+                  <a:srgbClr val="222222"/>
+                </a:solidFill>
+                <a:latin typeface="Calibri"/>
+              </a:rPr>
+              <a:t>•  Hipótesis: patrones en monto, tiempo y componentes PCA superan reglas estáticas.</a:t>
+            </a:r>
+          </a:p>
+          <a:p>
+            <a:pPr>
+              <a:spcAft>
+                <a:spcPts val="800"/>
+              </a:spcAft>
+            </a:pPr>
+            <a:r>
+              <a:rPr sz="1700" b="0">
+                <a:solidFill>
+                  <a:srgbClr val="222222"/>
+                </a:solidFill>
+                <a:latin typeface="Calibri"/>
+              </a:rPr>
+              <a:t>•  KPI técnicos: PR-AUC, Recall y Precision (no Accuracy ni solo FPR).</a:t>
+            </a:r>
+          </a:p>
+          <a:p>
+            <a:pPr>
+              <a:spcAft>
+                <a:spcPts val="800"/>
+              </a:spcAft>
+            </a:pPr>
+            <a:r>
+              <a:rPr sz="1700" b="0">
+                <a:solidFill>
+                  <a:srgbClr val="222222"/>
+                </a:solidFill>
+                <a:latin typeface="Calibri"/>
+              </a:rPr>
+              <a:t>•  KPI de negocio: ¿cuántos fraudes encontramos si revisamos Top-100 o Top-500?</a:t>
+            </a:r>
+          </a:p>
+          <a:p>
+            <a:pPr>
+              <a:spcAft>
+                <a:spcPts val="800"/>
+              </a:spcAft>
+            </a:pPr>
+            <a:r>
+              <a:rPr sz="1700" b="0">
+                <a:solidFill>
+                  <a:srgbClr val="222222"/>
+                </a:solidFill>
+                <a:latin typeface="Calibri"/>
+              </a:rPr>
+              <a:t>•  Restricción crítica: con tan pocos fraudes, FPR ≤ 5 % generaría miles de falsas alertas.</a:t>
+            </a:r>
+          </a:p>
+        </p:txBody>
+      </p:sp>
+      <p:sp>
+        <p:nvSpPr>
+          <p:cNvPr id="4" name="TextBox 3"/>
           <p:cNvSpPr txBox="1"/>
           <p:nvPr/>
         </p:nvSpPr>
         <p:spPr>
           <a:xfrm>
-            <a:off x="365760" y="6492240"/>
-            <a:ext cx="11430000" cy="274320"/>
+            <a:off x="365760" y="6537960"/>
+            <a:ext cx="11430000" cy="256032"/>
           </a:xfrm>
           <a:prstGeom prst="rect">
             <a:avLst/>
@@ -4586,7 +4713,7 @@
                 </a:solidFill>
                 <a:latin typeface="Calibri"/>
               </a:rPr>
-              <a:t>Grupo 33 · Detección de Fraude · 4/12</a:t>
+              <a:t>Grupo 33 · Detección de Fraude en Tarjetas de Crédito · 4/12</a:t>
             </a:r>
           </a:p>
         </p:txBody>
@@ -4618,7 +4745,7 @@
         <p:spPr>
           <a:xfrm>
             <a:off x="0" y="0"/>
-            <a:ext cx="12191695" cy="822960"/>
+            <a:ext cx="12191695" cy="777240"/>
           </a:xfrm>
           <a:prstGeom prst="rect">
             <a:avLst/>
@@ -4645,10 +4772,10 @@
           </a:fontRef>
         </p:style>
         <p:txBody>
-          <a:bodyPr rtlCol="0" anchor="ctr"/>
-          <a:lstStyle/>
-          <a:p>
-            <a:pPr algn="l"/>
+          <a:bodyPr rtlCol="0" anchor="ctr" wrap="square" lIns="320040" tIns="164592"/>
+          <a:lstStyle/>
+          <a:p>
+            <a:pPr algn="ctr"/>
             <a:r>
               <a:rPr sz="2200" b="1">
                 <a:solidFill>
@@ -4656,21 +4783,45 @@
                 </a:solidFill>
                 <a:latin typeface="Calibri"/>
               </a:rPr>
-              <a:t>  Metodología CRISP-DM</a:t>
-            </a:r>
-          </a:p>
-        </p:txBody>
-      </p:sp>
-      <p:sp>
-        <p:nvSpPr>
-          <p:cNvPr id="3" name="TextBox 2"/>
+              <a:t>3. Datos y metodología (CRISP-DM)</a:t>
+            </a:r>
+          </a:p>
+        </p:txBody>
+      </p:sp>
+      <p:pic>
+        <p:nvPicPr>
+          <p:cNvPr id="3" name="Picture 2" descr="01_class_distribution.png"/>
+          <p:cNvPicPr>
+            <a:picLocks noChangeAspect="1"/>
+          </p:cNvPicPr>
+          <p:nvPr/>
+        </p:nvPicPr>
+        <p:blipFill>
+          <a:blip r:embed="rId2"/>
+          <a:stretch>
+            <a:fillRect/>
+          </a:stretch>
+        </p:blipFill>
+        <p:spPr>
+          <a:xfrm>
+            <a:off x="411480" y="1051560"/>
+            <a:ext cx="5486400" cy="3145192"/>
+          </a:xfrm>
+          <a:prstGeom prst="rect">
+            <a:avLst/>
+          </a:prstGeom>
+        </p:spPr>
+      </p:pic>
+      <p:sp>
+        <p:nvSpPr>
+          <p:cNvPr id="4" name="TextBox 3"/>
           <p:cNvSpPr txBox="1"/>
           <p:nvPr/>
         </p:nvSpPr>
         <p:spPr>
           <a:xfrm>
-            <a:off x="731520" y="1280160"/>
-            <a:ext cx="10515600" cy="5029200"/>
+            <a:off x="6126480" y="1097280"/>
+            <a:ext cx="5577840" cy="5029200"/>
           </a:xfrm>
           <a:prstGeom prst="rect">
             <a:avLst/>
@@ -4678,102 +4829,118 @@
           <a:noFill/>
         </p:spPr>
         <p:txBody>
-          <a:bodyPr wrap="none">
+          <a:bodyPr wrap="square">
             <a:spAutoFit/>
           </a:bodyPr>
           <a:lstStyle/>
           <a:p>
             <a:pPr>
               <a:spcAft>
-                <a:spcPts val="600"/>
-              </a:spcAft>
-            </a:pPr>
-            <a:r>
-              <a:rPr sz="1700" b="0">
-                <a:solidFill>
-                  <a:srgbClr val="222222"/>
-                </a:solidFill>
-                <a:latin typeface="Calibri"/>
-              </a:rPr>
-              <a:t>Preparación en Pipeline: StandardScaler(Time, Amount_log) sin leakage.</a:t>
-            </a:r>
-          </a:p>
-          <a:p>
-            <a:pPr>
-              <a:spcAft>
-                <a:spcPts val="600"/>
-              </a:spcAft>
-            </a:pPr>
-            <a:r>
-              <a:rPr sz="1700" b="0">
-                <a:solidFill>
-                  <a:srgbClr val="222222"/>
-                </a:solidFill>
-                <a:latin typeface="Calibri"/>
-              </a:rPr>
-              <a:t>Modelos: Logistic Regression · Random Forest · XGBoost · LightGBM · XGBoost+SMOTE.</a:t>
-            </a:r>
-          </a:p>
-          <a:p>
-            <a:pPr>
-              <a:spcAft>
-                <a:spcPts val="600"/>
-              </a:spcAft>
-            </a:pPr>
-            <a:r>
-              <a:rPr sz="1700" b="0">
-                <a:solidFill>
-                  <a:srgbClr val="222222"/>
-                </a:solidFill>
-                <a:latin typeface="Calibri"/>
-              </a:rPr>
-              <a:t>Métricas principales: PR-AUC, Recall, Precision (+ F1, ROC-AUC).</a:t>
-            </a:r>
-          </a:p>
-          <a:p>
-            <a:pPr>
-              <a:spcAft>
-                <a:spcPts val="600"/>
-              </a:spcAft>
-            </a:pPr>
-            <a:r>
-              <a:rPr sz="1700" b="0">
-                <a:solidFill>
-                  <a:srgbClr val="222222"/>
-                </a:solidFill>
-                <a:latin typeface="Calibri"/>
-              </a:rPr>
-              <a:t>Negocio: captura Top-K y volumen de alertas por umbral.</a:t>
-            </a:r>
-          </a:p>
-          <a:p>
-            <a:pPr>
-              <a:spcAft>
-                <a:spcPts val="600"/>
-              </a:spcAft>
-            </a:pPr>
-            <a:r>
-              <a:rPr sz="1700" b="0">
-                <a:solidFill>
-                  <a:srgbClr val="222222"/>
-                </a:solidFill>
-                <a:latin typeface="Calibri"/>
-              </a:rPr>
-              <a:t>Validación: holdout estratificado 80/20  vs  split temporal por Time.</a:t>
-            </a:r>
-          </a:p>
-        </p:txBody>
-      </p:sp>
-      <p:sp>
-        <p:nvSpPr>
-          <p:cNvPr id="4" name="TextBox 3"/>
+                <a:spcPts val="800"/>
+              </a:spcAft>
+            </a:pPr>
+            <a:r>
+              <a:rPr sz="1500" b="0">
+                <a:solidFill>
+                  <a:srgbClr val="222222"/>
+                </a:solidFill>
+                <a:latin typeface="Calibri"/>
+              </a:rPr>
+              <a:t>•  Fuente: ULB / Kaggle (ODbL).</a:t>
+            </a:r>
+          </a:p>
+          <a:p>
+            <a:pPr>
+              <a:spcAft>
+                <a:spcPts val="800"/>
+              </a:spcAft>
+            </a:pPr>
+            <a:r>
+              <a:rPr sz="1500" b="0">
+                <a:solidFill>
+                  <a:srgbClr val="222222"/>
+                </a:solidFill>
+                <a:latin typeface="Calibri"/>
+              </a:rPr>
+              <a:t>•  Tras limpieza: 283,726 filas; 473 fraudes.</a:t>
+            </a:r>
+          </a:p>
+          <a:p>
+            <a:pPr>
+              <a:spcAft>
+                <a:spcPts val="800"/>
+              </a:spcAft>
+            </a:pPr>
+            <a:r>
+              <a:rPr sz="1500" b="0">
+                <a:solidFill>
+                  <a:srgbClr val="222222"/>
+                </a:solidFill>
+                <a:latin typeface="Calibri"/>
+              </a:rPr>
+              <a:t>•  Sin nulos; duplicados eliminados.</a:t>
+            </a:r>
+          </a:p>
+          <a:p>
+            <a:pPr>
+              <a:spcAft>
+                <a:spcPts val="800"/>
+              </a:spcAft>
+            </a:pPr>
+            <a:r>
+              <a:rPr sz="1500" b="0">
+                <a:solidFill>
+                  <a:srgbClr val="222222"/>
+                </a:solidFill>
+                <a:latin typeface="Calibri"/>
+              </a:rPr>
+              <a:t>•  Amount_log = log1p(Amount).</a:t>
+            </a:r>
+          </a:p>
+          <a:p>
+            <a:pPr>
+              <a:spcAft>
+                <a:spcPts val="800"/>
+              </a:spcAft>
+            </a:pPr>
+            <a:r>
+              <a:rPr sz="1500" b="0">
+                <a:solidFill>
+                  <a:srgbClr val="222222"/>
+                </a:solidFill>
+                <a:latin typeface="Calibri"/>
+              </a:rPr>
+              <a:t>•  Scaler de Time y Amount_log dentro del Pipeline (sin leakage).</a:t>
+            </a:r>
+          </a:p>
+          <a:p>
+            <a:pPr>
+              <a:spcAft>
+                <a:spcPts val="800"/>
+              </a:spcAft>
+            </a:pPr>
+            <a:r>
+              <a:rPr sz="1500" b="0">
+                <a:solidFill>
+                  <a:srgbClr val="222222"/>
+                </a:solidFill>
+                <a:latin typeface="Calibri"/>
+              </a:rPr>
+              <a:t>•  Validación: (A) aleatorio 80/20 estratificado; (B) temporal por Time.</a:t>
+            </a:r>
+          </a:p>
+        </p:txBody>
+      </p:sp>
+      <p:sp>
+        <p:nvSpPr>
+          <p:cNvPr id="5" name="TextBox 4"/>
           <p:cNvSpPr txBox="1"/>
           <p:nvPr/>
         </p:nvSpPr>
         <p:spPr>
           <a:xfrm>
-            <a:off x="365760" y="6492240"/>
-            <a:ext cx="11430000" cy="274320"/>
+            <a:off x="365760" y="6537960"/>
+            <a:ext cx="11430000" cy="256032"/>
           </a:xfrm>
           <a:prstGeom prst="rect">
             <a:avLst/>
@@ -4793,7 +4960,7 @@
                 </a:solidFill>
                 <a:latin typeface="Calibri"/>
               </a:rPr>
-              <a:t>Grupo 33 · Detección de Fraude · 5/12</a:t>
+              <a:t>Grupo 33 · Detección de Fraude en Tarjetas de Crédito · 5/12</a:t>
             </a:r>
           </a:p>
         </p:txBody>
@@ -4825,7 +4992,7 @@
         <p:spPr>
           <a:xfrm>
             <a:off x="0" y="0"/>
-            <a:ext cx="12191695" cy="822960"/>
+            <a:ext cx="12191695" cy="777240"/>
           </a:xfrm>
           <a:prstGeom prst="rect">
             <a:avLst/>
@@ -4852,10 +5019,10 @@
           </a:fontRef>
         </p:style>
         <p:txBody>
-          <a:bodyPr rtlCol="0" anchor="ctr"/>
-          <a:lstStyle/>
-          <a:p>
-            <a:pPr algn="l"/>
+          <a:bodyPr rtlCol="0" anchor="ctr" wrap="square" lIns="320040" tIns="164592"/>
+          <a:lstStyle/>
+          <a:p>
+            <a:pPr algn="ctr"/>
             <a:r>
               <a:rPr sz="2200" b="1">
                 <a:solidFill>
@@ -4863,309 +5030,21 @@
                 </a:solidFill>
                 <a:latin typeface="Calibri"/>
               </a:rPr>
-              <a:t>  Resultados clave — modelo: XGBoost</a:t>
-            </a:r>
-          </a:p>
-        </p:txBody>
-      </p:sp>
-      <p:sp>
-        <p:nvSpPr>
-          <p:cNvPr id="3" name="Rounded Rectangle 2"/>
-          <p:cNvSpPr/>
-          <p:nvPr/>
-        </p:nvSpPr>
-        <p:spPr>
-          <a:xfrm>
-            <a:off x="640080" y="1280160"/>
-            <a:ext cx="2651760" cy="1463040"/>
-          </a:xfrm>
-          <a:prstGeom prst="roundRect">
-            <a:avLst/>
-          </a:prstGeom>
-          <a:solidFill>
-            <a:srgbClr val="EEF5FB"/>
-          </a:solidFill>
-          <a:ln>
-            <a:solidFill>
-              <a:srgbClr val="1F4E79"/>
-            </a:solidFill>
-          </a:ln>
-        </p:spPr>
-        <p:style>
-          <a:lnRef idx="1">
-            <a:schemeClr val="accent1"/>
-          </a:lnRef>
-          <a:fillRef idx="3">
-            <a:schemeClr val="accent1"/>
-          </a:fillRef>
-          <a:effectRef idx="2">
-            <a:schemeClr val="accent1"/>
-          </a:effectRef>
-          <a:fontRef idx="minor">
-            <a:schemeClr val="lt1"/>
-          </a:fontRef>
-        </p:style>
-        <p:txBody>
-          <a:bodyPr rtlCol="0" anchor="ctr"/>
-          <a:lstStyle/>
-          <a:p>
-            <a:pPr algn="ctr"/>
-            <a:r>
-              <a:rPr sz="1400" b="0">
-                <a:solidFill>
-                  <a:srgbClr val="555555"/>
-                </a:solidFill>
-                <a:latin typeface="Calibri"/>
-              </a:rPr>
-              <a:t>PR-AUC</a:t>
-            </a:r>
-          </a:p>
-          <a:p>
-            <a:pPr algn="ctr"/>
-            <a:r>
-              <a:rPr sz="2800" b="1">
-                <a:solidFill>
-                  <a:srgbClr val="1F4E79"/>
-                </a:solidFill>
-                <a:latin typeface="Calibri"/>
-              </a:rPr>
-              <a:t>0.827</a:t>
-            </a:r>
-          </a:p>
-        </p:txBody>
-      </p:sp>
-      <p:sp>
-        <p:nvSpPr>
-          <p:cNvPr id="4" name="Rounded Rectangle 3"/>
-          <p:cNvSpPr/>
-          <p:nvPr/>
-        </p:nvSpPr>
-        <p:spPr>
-          <a:xfrm>
-            <a:off x="3474720" y="1280160"/>
-            <a:ext cx="2651760" cy="1463040"/>
-          </a:xfrm>
-          <a:prstGeom prst="roundRect">
-            <a:avLst/>
-          </a:prstGeom>
-          <a:solidFill>
-            <a:srgbClr val="EEF5FB"/>
-          </a:solidFill>
-          <a:ln>
-            <a:solidFill>
-              <a:srgbClr val="1F4E79"/>
-            </a:solidFill>
-          </a:ln>
-        </p:spPr>
-        <p:style>
-          <a:lnRef idx="1">
-            <a:schemeClr val="accent1"/>
-          </a:lnRef>
-          <a:fillRef idx="3">
-            <a:schemeClr val="accent1"/>
-          </a:fillRef>
-          <a:effectRef idx="2">
-            <a:schemeClr val="accent1"/>
-          </a:effectRef>
-          <a:fontRef idx="minor">
-            <a:schemeClr val="lt1"/>
-          </a:fontRef>
-        </p:style>
-        <p:txBody>
-          <a:bodyPr rtlCol="0" anchor="ctr"/>
-          <a:lstStyle/>
-          <a:p>
-            <a:pPr algn="ctr"/>
-            <a:r>
-              <a:rPr sz="1400" b="0">
-                <a:solidFill>
-                  <a:srgbClr val="555555"/>
-                </a:solidFill>
-                <a:latin typeface="Calibri"/>
-              </a:rPr>
-              <a:t>Recall</a:t>
-            </a:r>
-          </a:p>
-          <a:p>
-            <a:pPr algn="ctr"/>
-            <a:r>
-              <a:rPr sz="2800" b="1">
-                <a:solidFill>
-                  <a:srgbClr val="1F4E79"/>
-                </a:solidFill>
-                <a:latin typeface="Calibri"/>
-              </a:rPr>
-              <a:t>81.1%</a:t>
-            </a:r>
-          </a:p>
-        </p:txBody>
-      </p:sp>
-      <p:sp>
-        <p:nvSpPr>
-          <p:cNvPr id="5" name="Rounded Rectangle 4"/>
-          <p:cNvSpPr/>
-          <p:nvPr/>
-        </p:nvSpPr>
-        <p:spPr>
-          <a:xfrm>
-            <a:off x="6309360" y="1280160"/>
-            <a:ext cx="2651760" cy="1463040"/>
-          </a:xfrm>
-          <a:prstGeom prst="roundRect">
-            <a:avLst/>
-          </a:prstGeom>
-          <a:solidFill>
-            <a:srgbClr val="EEF5FB"/>
-          </a:solidFill>
-          <a:ln>
-            <a:solidFill>
-              <a:srgbClr val="1F4E79"/>
-            </a:solidFill>
-          </a:ln>
-        </p:spPr>
-        <p:style>
-          <a:lnRef idx="1">
-            <a:schemeClr val="accent1"/>
-          </a:lnRef>
-          <a:fillRef idx="3">
-            <a:schemeClr val="accent1"/>
-          </a:fillRef>
-          <a:effectRef idx="2">
-            <a:schemeClr val="accent1"/>
-          </a:effectRef>
-          <a:fontRef idx="minor">
-            <a:schemeClr val="lt1"/>
-          </a:fontRef>
-        </p:style>
-        <p:txBody>
-          <a:bodyPr rtlCol="0" anchor="ctr"/>
-          <a:lstStyle/>
-          <a:p>
-            <a:pPr algn="ctr"/>
-            <a:r>
-              <a:rPr sz="1400" b="0">
-                <a:solidFill>
-                  <a:srgbClr val="555555"/>
-                </a:solidFill>
-                <a:latin typeface="Calibri"/>
-              </a:rPr>
-              <a:t>Precision</a:t>
-            </a:r>
-          </a:p>
-          <a:p>
-            <a:pPr algn="ctr"/>
-            <a:r>
-              <a:rPr sz="2800" b="1">
-                <a:solidFill>
-                  <a:srgbClr val="1F4E79"/>
-                </a:solidFill>
-                <a:latin typeface="Calibri"/>
-              </a:rPr>
-              <a:t>86.5%</a:t>
-            </a:r>
-          </a:p>
-        </p:txBody>
-      </p:sp>
-      <p:sp>
-        <p:nvSpPr>
-          <p:cNvPr id="6" name="Rounded Rectangle 5"/>
-          <p:cNvSpPr/>
-          <p:nvPr/>
-        </p:nvSpPr>
-        <p:spPr>
-          <a:xfrm>
-            <a:off x="9144000" y="1280160"/>
-            <a:ext cx="2651760" cy="1463040"/>
-          </a:xfrm>
-          <a:prstGeom prst="roundRect">
-            <a:avLst/>
-          </a:prstGeom>
-          <a:solidFill>
-            <a:srgbClr val="EEF5FB"/>
-          </a:solidFill>
-          <a:ln>
-            <a:solidFill>
-              <a:srgbClr val="1F4E79"/>
-            </a:solidFill>
-          </a:ln>
-        </p:spPr>
-        <p:style>
-          <a:lnRef idx="1">
-            <a:schemeClr val="accent1"/>
-          </a:lnRef>
-          <a:fillRef idx="3">
-            <a:schemeClr val="accent1"/>
-          </a:fillRef>
-          <a:effectRef idx="2">
-            <a:schemeClr val="accent1"/>
-          </a:effectRef>
-          <a:fontRef idx="minor">
-            <a:schemeClr val="lt1"/>
-          </a:fontRef>
-        </p:style>
-        <p:txBody>
-          <a:bodyPr rtlCol="0" anchor="ctr"/>
-          <a:lstStyle/>
-          <a:p>
-            <a:pPr algn="ctr"/>
-            <a:r>
-              <a:rPr sz="1400" b="0">
-                <a:solidFill>
-                  <a:srgbClr val="555555"/>
-                </a:solidFill>
-                <a:latin typeface="Calibri"/>
-              </a:rPr>
-              <a:t>F1</a:t>
-            </a:r>
-          </a:p>
-          <a:p>
-            <a:pPr algn="ctr"/>
-            <a:r>
-              <a:rPr sz="2800" b="1">
-                <a:solidFill>
-                  <a:srgbClr val="1F4E79"/>
-                </a:solidFill>
-                <a:latin typeface="Calibri"/>
-              </a:rPr>
-              <a:t>0.837</a:t>
-            </a:r>
-          </a:p>
-        </p:txBody>
-      </p:sp>
-      <p:pic>
-        <p:nvPicPr>
-          <p:cNvPr id="7" name="Picture 6" descr="06_pr_curve_aleatorio.png"/>
-          <p:cNvPicPr>
-            <a:picLocks noChangeAspect="1"/>
-          </p:cNvPicPr>
-          <p:nvPr/>
-        </p:nvPicPr>
-        <p:blipFill>
-          <a:blip r:embed="rId2"/>
-          <a:stretch>
-            <a:fillRect/>
-          </a:stretch>
-        </p:blipFill>
-        <p:spPr>
-          <a:xfrm>
-            <a:off x="3200400" y="3017520"/>
-            <a:ext cx="5486400" cy="5325710"/>
-          </a:xfrm>
-          <a:prstGeom prst="rect">
-            <a:avLst/>
-          </a:prstGeom>
-        </p:spPr>
-      </p:pic>
-      <p:sp>
-        <p:nvSpPr>
-          <p:cNvPr id="8" name="TextBox 7"/>
+              <a:t>4. Modelos evaluados y criterio de selección</a:t>
+            </a:r>
+          </a:p>
+        </p:txBody>
+      </p:sp>
+      <p:sp>
+        <p:nvSpPr>
+          <p:cNvPr id="3" name="TextBox 2"/>
           <p:cNvSpPr txBox="1"/>
           <p:nvPr/>
         </p:nvSpPr>
         <p:spPr>
           <a:xfrm>
-            <a:off x="365760" y="6492240"/>
-            <a:ext cx="11430000" cy="274320"/>
+            <a:off x="548640" y="1051560"/>
+            <a:ext cx="11064240" cy="2194560"/>
           </a:xfrm>
           <a:prstGeom prst="rect">
             <a:avLst/>
@@ -5173,6 +5052,196 @@
           <a:noFill/>
         </p:spPr>
         <p:txBody>
+          <a:bodyPr wrap="square">
+            <a:spAutoFit/>
+          </a:bodyPr>
+          <a:lstStyle/>
+          <a:p>
+            <a:pPr>
+              <a:spcAft>
+                <a:spcPts val="800"/>
+              </a:spcAft>
+            </a:pPr>
+            <a:r>
+              <a:rPr sz="1600" b="0">
+                <a:solidFill>
+                  <a:srgbClr val="222222"/>
+                </a:solidFill>
+                <a:latin typeface="Calibri"/>
+              </a:rPr>
+              <a:t>•  Baseline: Regresión Logística (class_weight=balanced).</a:t>
+            </a:r>
+          </a:p>
+          <a:p>
+            <a:pPr>
+              <a:spcAft>
+                <a:spcPts val="800"/>
+              </a:spcAft>
+            </a:pPr>
+            <a:r>
+              <a:rPr sz="1600" b="0">
+                <a:solidFill>
+                  <a:srgbClr val="222222"/>
+                </a:solidFill>
+                <a:latin typeface="Calibri"/>
+              </a:rPr>
+              <a:t>•  Alternativas: Random Forest · XGBoost · LightGBM · XGBoost+SMOTE.</a:t>
+            </a:r>
+          </a:p>
+          <a:p>
+            <a:pPr>
+              <a:spcAft>
+                <a:spcPts val="800"/>
+              </a:spcAft>
+            </a:pPr>
+            <a:r>
+              <a:rPr sz="1600" b="0">
+                <a:solidFill>
+                  <a:srgbClr val="222222"/>
+                </a:solidFill>
+                <a:latin typeface="Calibri"/>
+              </a:rPr>
+              <a:t>•  Selección por PR-AUC (ranking bajo desbalance), con Recall/Precision y carga de alertas.</a:t>
+            </a:r>
+          </a:p>
+          <a:p>
+            <a:pPr>
+              <a:spcAft>
+                <a:spcPts val="800"/>
+              </a:spcAft>
+            </a:pPr>
+            <a:r>
+              <a:rPr sz="1600" b="0">
+                <a:solidFill>
+                  <a:srgbClr val="222222"/>
+                </a:solidFill>
+                <a:latin typeface="Calibri"/>
+              </a:rPr>
+              <a:t>•  Modelo elegido: XGBoost — mejor equilibrio detección / alertas útiles.</a:t>
+            </a:r>
+          </a:p>
+        </p:txBody>
+      </p:sp>
+      <p:sp>
+        <p:nvSpPr>
+          <p:cNvPr id="4" name="TextBox 3"/>
+          <p:cNvSpPr txBox="1"/>
+          <p:nvPr/>
+        </p:nvSpPr>
+        <p:spPr>
+          <a:xfrm>
+            <a:off x="548640" y="3383280"/>
+            <a:ext cx="11064240" cy="2926080"/>
+          </a:xfrm>
+          <a:prstGeom prst="rect">
+            <a:avLst/>
+          </a:prstGeom>
+          <a:noFill/>
+        </p:spPr>
+        <p:txBody>
+          <a:bodyPr wrap="square">
+            <a:spAutoFit/>
+          </a:bodyPr>
+          <a:lstStyle/>
+          <a:p>
+            <a:pPr>
+              <a:spcAft>
+                <a:spcPts val="800"/>
+              </a:spcAft>
+            </a:pPr>
+            <a:r>
+              <a:rPr sz="1400" b="0">
+                <a:solidFill>
+                  <a:srgbClr val="222222"/>
+                </a:solidFill>
+                <a:latin typeface="Calibri"/>
+              </a:rPr>
+              <a:t>•  LogisticRegression: PR-AUC 0.677 · R 87.4% · P 5.5%</a:t>
+            </a:r>
+          </a:p>
+          <a:p>
+            <a:pPr>
+              <a:spcAft>
+                <a:spcPts val="800"/>
+              </a:spcAft>
+            </a:pPr>
+            <a:r>
+              <a:rPr sz="1400" b="0">
+                <a:solidFill>
+                  <a:srgbClr val="222222"/>
+                </a:solidFill>
+                <a:latin typeface="Calibri"/>
+              </a:rPr>
+              <a:t>•  RandomForest: PR-AUC 0.799 · R 74.7% · P 89.9%</a:t>
+            </a:r>
+          </a:p>
+          <a:p>
+            <a:pPr>
+              <a:spcAft>
+                <a:spcPts val="800"/>
+              </a:spcAft>
+            </a:pPr>
+            <a:r>
+              <a:rPr sz="1400" b="0">
+                <a:solidFill>
+                  <a:srgbClr val="222222"/>
+                </a:solidFill>
+                <a:latin typeface="Calibri"/>
+              </a:rPr>
+              <a:t>•  XGBoost: PR-AUC 0.827 · R 81.1% · P 86.5% ← elegido</a:t>
+            </a:r>
+          </a:p>
+          <a:p>
+            <a:pPr>
+              <a:spcAft>
+                <a:spcPts val="800"/>
+              </a:spcAft>
+            </a:pPr>
+            <a:r>
+              <a:rPr sz="1400" b="0">
+                <a:solidFill>
+                  <a:srgbClr val="222222"/>
+                </a:solidFill>
+                <a:latin typeface="Calibri"/>
+              </a:rPr>
+              <a:t>•  LightGBM: PR-AUC 0.048 · R 76.8% · P 6.0%</a:t>
+            </a:r>
+          </a:p>
+          <a:p>
+            <a:pPr>
+              <a:spcAft>
+                <a:spcPts val="800"/>
+              </a:spcAft>
+            </a:pPr>
+            <a:r>
+              <a:rPr sz="1400" b="0">
+                <a:solidFill>
+                  <a:srgbClr val="222222"/>
+                </a:solidFill>
+                <a:latin typeface="Calibri"/>
+              </a:rPr>
+              <a:t>•  XGBoost_SMOTE: PR-AUC 0.765 · R 84.2% · P 7.9%</a:t>
+            </a:r>
+          </a:p>
+        </p:txBody>
+      </p:sp>
+      <p:sp>
+        <p:nvSpPr>
+          <p:cNvPr id="5" name="TextBox 4"/>
+          <p:cNvSpPr txBox="1"/>
+          <p:nvPr/>
+        </p:nvSpPr>
+        <p:spPr>
+          <a:xfrm>
+            <a:off x="365760" y="6537960"/>
+            <a:ext cx="11430000" cy="256032"/>
+          </a:xfrm>
+          <a:prstGeom prst="rect">
+            <a:avLst/>
+          </a:prstGeom>
+          <a:noFill/>
+        </p:spPr>
+        <p:txBody>
           <a:bodyPr wrap="none">
             <a:spAutoFit/>
           </a:bodyPr>
@@ -5185,7 +5254,7 @@
                 </a:solidFill>
                 <a:latin typeface="Calibri"/>
               </a:rPr>
-              <a:t>Grupo 33 · Detección de Fraude · 6/12</a:t>
+              <a:t>Grupo 33 · Detección de Fraude en Tarjetas de Crédito · 6/12</a:t>
             </a:r>
           </a:p>
         </p:txBody>
@@ -5217,7 +5286,7 @@
         <p:spPr>
           <a:xfrm>
             <a:off x="0" y="0"/>
-            <a:ext cx="12191695" cy="822960"/>
+            <a:ext cx="12191695" cy="777240"/>
           </a:xfrm>
           <a:prstGeom prst="rect">
             <a:avLst/>
@@ -5244,10 +5313,10 @@
           </a:fontRef>
         </p:style>
         <p:txBody>
-          <a:bodyPr rtlCol="0" anchor="ctr"/>
-          <a:lstStyle/>
-          <a:p>
-            <a:pPr algn="l"/>
+          <a:bodyPr rtlCol="0" anchor="ctr" wrap="square" lIns="320040" tIns="164592"/>
+          <a:lstStyle/>
+          <a:p>
+            <a:pPr algn="ctr"/>
             <a:r>
               <a:rPr sz="2200" b="1">
                 <a:solidFill>
@@ -5255,14 +5324,278 @@
                 </a:solidFill>
                 <a:latin typeface="Calibri"/>
               </a:rPr>
-              <a:t>  Métrica de negocio: ¿cuántos fraudes si revisamos Top-K?</a:t>
+              <a:t>5. Resultados clave — holdout aleatorio</a:t>
+            </a:r>
+          </a:p>
+        </p:txBody>
+      </p:sp>
+      <p:sp>
+        <p:nvSpPr>
+          <p:cNvPr id="3" name="Rounded Rectangle 2"/>
+          <p:cNvSpPr/>
+          <p:nvPr/>
+        </p:nvSpPr>
+        <p:spPr>
+          <a:xfrm>
+            <a:off x="502920" y="1051560"/>
+            <a:ext cx="2606040" cy="1234440"/>
+          </a:xfrm>
+          <a:prstGeom prst="roundRect">
+            <a:avLst/>
+          </a:prstGeom>
+          <a:solidFill>
+            <a:srgbClr val="EEF5FB"/>
+          </a:solidFill>
+          <a:ln>
+            <a:solidFill>
+              <a:srgbClr val="1F4E79"/>
+            </a:solidFill>
+          </a:ln>
+        </p:spPr>
+        <p:style>
+          <a:lnRef idx="1">
+            <a:schemeClr val="accent1"/>
+          </a:lnRef>
+          <a:fillRef idx="3">
+            <a:schemeClr val="accent1"/>
+          </a:fillRef>
+          <a:effectRef idx="2">
+            <a:schemeClr val="accent1"/>
+          </a:effectRef>
+          <a:fontRef idx="minor">
+            <a:schemeClr val="lt1"/>
+          </a:fontRef>
+        </p:style>
+        <p:txBody>
+          <a:bodyPr rtlCol="0" anchor="ctr" wrap="square"/>
+          <a:lstStyle/>
+          <a:p>
+            <a:pPr algn="ctr"/>
+            <a:r>
+              <a:rPr sz="1200" b="0">
+                <a:solidFill>
+                  <a:srgbClr val="555555"/>
+                </a:solidFill>
+                <a:latin typeface="Calibri"/>
+              </a:rPr>
+              <a:t>PR-AUC</a:t>
+            </a:r>
+          </a:p>
+          <a:p>
+            <a:pPr algn="ctr"/>
+            <a:r>
+              <a:rPr sz="2400" b="1">
+                <a:solidFill>
+                  <a:srgbClr val="1F4E79"/>
+                </a:solidFill>
+                <a:latin typeface="Calibri"/>
+              </a:rPr>
+              <a:t>0.827</a:t>
+            </a:r>
+          </a:p>
+        </p:txBody>
+      </p:sp>
+      <p:sp>
+        <p:nvSpPr>
+          <p:cNvPr id="4" name="Rounded Rectangle 3"/>
+          <p:cNvSpPr/>
+          <p:nvPr/>
+        </p:nvSpPr>
+        <p:spPr>
+          <a:xfrm>
+            <a:off x="3383280" y="1051560"/>
+            <a:ext cx="2606040" cy="1234440"/>
+          </a:xfrm>
+          <a:prstGeom prst="roundRect">
+            <a:avLst/>
+          </a:prstGeom>
+          <a:solidFill>
+            <a:srgbClr val="EEF5FB"/>
+          </a:solidFill>
+          <a:ln>
+            <a:solidFill>
+              <a:srgbClr val="1F4E79"/>
+            </a:solidFill>
+          </a:ln>
+        </p:spPr>
+        <p:style>
+          <a:lnRef idx="1">
+            <a:schemeClr val="accent1"/>
+          </a:lnRef>
+          <a:fillRef idx="3">
+            <a:schemeClr val="accent1"/>
+          </a:fillRef>
+          <a:effectRef idx="2">
+            <a:schemeClr val="accent1"/>
+          </a:effectRef>
+          <a:fontRef idx="minor">
+            <a:schemeClr val="lt1"/>
+          </a:fontRef>
+        </p:style>
+        <p:txBody>
+          <a:bodyPr rtlCol="0" anchor="ctr" wrap="square"/>
+          <a:lstStyle/>
+          <a:p>
+            <a:pPr algn="ctr"/>
+            <a:r>
+              <a:rPr sz="1200" b="0">
+                <a:solidFill>
+                  <a:srgbClr val="555555"/>
+                </a:solidFill>
+                <a:latin typeface="Calibri"/>
+              </a:rPr>
+              <a:t>Recall</a:t>
+            </a:r>
+          </a:p>
+          <a:p>
+            <a:pPr algn="ctr"/>
+            <a:r>
+              <a:rPr sz="2400" b="1">
+                <a:solidFill>
+                  <a:srgbClr val="1F4E79"/>
+                </a:solidFill>
+                <a:latin typeface="Calibri"/>
+              </a:rPr>
+              <a:t>81.1%</a:t>
+            </a:r>
+          </a:p>
+        </p:txBody>
+      </p:sp>
+      <p:sp>
+        <p:nvSpPr>
+          <p:cNvPr id="5" name="Rounded Rectangle 4"/>
+          <p:cNvSpPr/>
+          <p:nvPr/>
+        </p:nvSpPr>
+        <p:spPr>
+          <a:xfrm>
+            <a:off x="6263640" y="1051560"/>
+            <a:ext cx="2606040" cy="1234440"/>
+          </a:xfrm>
+          <a:prstGeom prst="roundRect">
+            <a:avLst/>
+          </a:prstGeom>
+          <a:solidFill>
+            <a:srgbClr val="EEF5FB"/>
+          </a:solidFill>
+          <a:ln>
+            <a:solidFill>
+              <a:srgbClr val="1F4E79"/>
+            </a:solidFill>
+          </a:ln>
+        </p:spPr>
+        <p:style>
+          <a:lnRef idx="1">
+            <a:schemeClr val="accent1"/>
+          </a:lnRef>
+          <a:fillRef idx="3">
+            <a:schemeClr val="accent1"/>
+          </a:fillRef>
+          <a:effectRef idx="2">
+            <a:schemeClr val="accent1"/>
+          </a:effectRef>
+          <a:fontRef idx="minor">
+            <a:schemeClr val="lt1"/>
+          </a:fontRef>
+        </p:style>
+        <p:txBody>
+          <a:bodyPr rtlCol="0" anchor="ctr" wrap="square"/>
+          <a:lstStyle/>
+          <a:p>
+            <a:pPr algn="ctr"/>
+            <a:r>
+              <a:rPr sz="1200" b="0">
+                <a:solidFill>
+                  <a:srgbClr val="555555"/>
+                </a:solidFill>
+                <a:latin typeface="Calibri"/>
+              </a:rPr>
+              <a:t>Precision</a:t>
+            </a:r>
+          </a:p>
+          <a:p>
+            <a:pPr algn="ctr"/>
+            <a:r>
+              <a:rPr sz="2400" b="1">
+                <a:solidFill>
+                  <a:srgbClr val="1F4E79"/>
+                </a:solidFill>
+                <a:latin typeface="Calibri"/>
+              </a:rPr>
+              <a:t>86.5%</a:t>
+            </a:r>
+          </a:p>
+        </p:txBody>
+      </p:sp>
+      <p:sp>
+        <p:nvSpPr>
+          <p:cNvPr id="6" name="Rounded Rectangle 5"/>
+          <p:cNvSpPr/>
+          <p:nvPr/>
+        </p:nvSpPr>
+        <p:spPr>
+          <a:xfrm>
+            <a:off x="9144000" y="1051560"/>
+            <a:ext cx="2606040" cy="1234440"/>
+          </a:xfrm>
+          <a:prstGeom prst="roundRect">
+            <a:avLst/>
+          </a:prstGeom>
+          <a:solidFill>
+            <a:srgbClr val="EEF5FB"/>
+          </a:solidFill>
+          <a:ln>
+            <a:solidFill>
+              <a:srgbClr val="1F4E79"/>
+            </a:solidFill>
+          </a:ln>
+        </p:spPr>
+        <p:style>
+          <a:lnRef idx="1">
+            <a:schemeClr val="accent1"/>
+          </a:lnRef>
+          <a:fillRef idx="3">
+            <a:schemeClr val="accent1"/>
+          </a:fillRef>
+          <a:effectRef idx="2">
+            <a:schemeClr val="accent1"/>
+          </a:effectRef>
+          <a:fontRef idx="minor">
+            <a:schemeClr val="lt1"/>
+          </a:fontRef>
+        </p:style>
+        <p:txBody>
+          <a:bodyPr rtlCol="0" anchor="ctr" wrap="square"/>
+          <a:lstStyle/>
+          <a:p>
+            <a:pPr algn="ctr"/>
+            <a:r>
+              <a:rPr sz="1200" b="0">
+                <a:solidFill>
+                  <a:srgbClr val="555555"/>
+                </a:solidFill>
+                <a:latin typeface="Calibri"/>
+              </a:rPr>
+              <a:t>F1</a:t>
+            </a:r>
+          </a:p>
+          <a:p>
+            <a:pPr algn="ctr"/>
+            <a:r>
+              <a:rPr sz="2400" b="1">
+                <a:solidFill>
+                  <a:srgbClr val="1F4E79"/>
+                </a:solidFill>
+                <a:latin typeface="Calibri"/>
+              </a:rPr>
+              <a:t>0.837</a:t>
             </a:r>
           </a:p>
         </p:txBody>
       </p:sp>
       <p:pic>
         <p:nvPicPr>
-          <p:cNvPr id="3" name="Picture 2" descr="08_captura_topk_aleatorio.png"/>
+          <p:cNvPr id="7" name="Picture 6" descr="06_pr_curve_aleatorio.png"/>
           <p:cNvPicPr>
             <a:picLocks noChangeAspect="1"/>
           </p:cNvPicPr>
@@ -5276,24 +5609,48 @@
         </p:blipFill>
         <p:spPr>
           <a:xfrm>
-            <a:off x="457200" y="1097280"/>
-            <a:ext cx="6400800" cy="3031081"/>
+            <a:off x="548640" y="2514600"/>
+            <a:ext cx="3459719" cy="3657600"/>
           </a:xfrm>
           <a:prstGeom prst="rect">
             <a:avLst/>
           </a:prstGeom>
         </p:spPr>
       </p:pic>
-      <p:sp>
-        <p:nvSpPr>
-          <p:cNvPr id="4" name="TextBox 3"/>
+      <p:pic>
+        <p:nvPicPr>
+          <p:cNvPr id="8" name="Picture 7" descr="07_confusion_aleatorio.png"/>
+          <p:cNvPicPr>
+            <a:picLocks noChangeAspect="1"/>
+          </p:cNvPicPr>
+          <p:nvPr/>
+        </p:nvPicPr>
+        <p:blipFill>
+          <a:blip r:embed="rId3"/>
+          <a:stretch>
+            <a:fillRect/>
+          </a:stretch>
+        </p:blipFill>
+        <p:spPr>
+          <a:xfrm>
+            <a:off x="6400800" y="2514600"/>
+            <a:ext cx="3247269" cy="3657600"/>
+          </a:xfrm>
+          <a:prstGeom prst="rect">
+            <a:avLst/>
+          </a:prstGeom>
+        </p:spPr>
+      </p:pic>
+      <p:sp>
+        <p:nvSpPr>
+          <p:cNvPr id="9" name="TextBox 8"/>
           <p:cNvSpPr txBox="1"/>
           <p:nvPr/>
         </p:nvSpPr>
         <p:spPr>
           <a:xfrm>
-            <a:off x="7040880" y="1645920"/>
-            <a:ext cx="4572000" cy="4114800"/>
+            <a:off x="365760" y="6537960"/>
+            <a:ext cx="11430000" cy="256032"/>
           </a:xfrm>
           <a:prstGeom prst="rect">
             <a:avLst/>
@@ -5306,109 +5663,6 @@
           </a:bodyPr>
           <a:lstStyle/>
           <a:p>
-            <a:pPr>
-              <a:spcAft>
-                <a:spcPts val="600"/>
-              </a:spcAft>
-            </a:pPr>
-            <a:r>
-              <a:rPr sz="1600" b="0">
-                <a:solidFill>
-                  <a:srgbClr val="222222"/>
-                </a:solidFill>
-                <a:latin typeface="Calibri"/>
-              </a:rPr>
-              <a:t>Top-100 → 77 fraudes</a:t>
-            </a:r>
-          </a:p>
-          <a:p>
-            <a:pPr>
-              <a:spcAft>
-                <a:spcPts val="600"/>
-              </a:spcAft>
-            </a:pPr>
-            <a:r>
-              <a:rPr sz="1600" b="0">
-                <a:solidFill>
-                  <a:srgbClr val="222222"/>
-                </a:solidFill>
-                <a:latin typeface="Calibri"/>
-              </a:rPr>
-              <a:t>Precision@100 = 77.0%</a:t>
-            </a:r>
-          </a:p>
-          <a:p>
-            <a:pPr>
-              <a:spcAft>
-                <a:spcPts val="600"/>
-              </a:spcAft>
-            </a:pPr>
-            <a:r>
-              <a:rPr sz="1600" b="0">
-                <a:solidFill>
-                  <a:srgbClr val="222222"/>
-                </a:solidFill>
-                <a:latin typeface="Calibri"/>
-              </a:rPr>
-              <a:t>Top-500 → 82 fraudes</a:t>
-            </a:r>
-          </a:p>
-          <a:p>
-            <a:pPr>
-              <a:spcAft>
-                <a:spcPts val="600"/>
-              </a:spcAft>
-            </a:pPr>
-            <a:r>
-              <a:rPr sz="1600" b="0">
-                <a:solidFill>
-                  <a:srgbClr val="222222"/>
-                </a:solidFill>
-                <a:latin typeface="Calibri"/>
-              </a:rPr>
-              <a:t>Lift@500 = 98.0×</a:t>
-            </a:r>
-          </a:p>
-          <a:p>
-            <a:pPr>
-              <a:spcAft>
-                <a:spcPts val="600"/>
-              </a:spcAft>
-            </a:pPr>
-            <a:r>
-              <a:rPr sz="1600" b="0">
-                <a:solidFill>
-                  <a:srgbClr val="222222"/>
-                </a:solidFill>
-                <a:latin typeface="Calibri"/>
-              </a:rPr>
-              <a:t>Traduce el score a una cola de revisión realista para el equipo.</a:t>
-            </a:r>
-          </a:p>
-        </p:txBody>
-      </p:sp>
-      <p:sp>
-        <p:nvSpPr>
-          <p:cNvPr id="5" name="TextBox 4"/>
-          <p:cNvSpPr txBox="1"/>
-          <p:nvPr/>
-        </p:nvSpPr>
-        <p:spPr>
-          <a:xfrm>
-            <a:off x="365760" y="6492240"/>
-            <a:ext cx="11430000" cy="274320"/>
-          </a:xfrm>
-          <a:prstGeom prst="rect">
-            <a:avLst/>
-          </a:prstGeom>
-          <a:noFill/>
-        </p:spPr>
-        <p:txBody>
-          <a:bodyPr wrap="none">
-            <a:spAutoFit/>
-          </a:bodyPr>
-          <a:lstStyle/>
-          <a:p>
             <a:r>
               <a:rPr sz="1000" b="0">
                 <a:solidFill>
@@ -5416,7 +5670,7 @@
                 </a:solidFill>
                 <a:latin typeface="Calibri"/>
               </a:rPr>
-              <a:t>Grupo 33 · Detección de Fraude · 7/12</a:t>
+              <a:t>Grupo 33 · Detección de Fraude en Tarjetas de Crédito · 7/12</a:t>
             </a:r>
           </a:p>
         </p:txBody>
@@ -5448,7 +5702,7 @@
         <p:spPr>
           <a:xfrm>
             <a:off x="0" y="0"/>
-            <a:ext cx="12191695" cy="822960"/>
+            <a:ext cx="12191695" cy="777240"/>
           </a:xfrm>
           <a:prstGeom prst="rect">
             <a:avLst/>
@@ -5475,10 +5729,10 @@
           </a:fontRef>
         </p:style>
         <p:txBody>
-          <a:bodyPr rtlCol="0" anchor="ctr"/>
-          <a:lstStyle/>
-          <a:p>
-            <a:pPr algn="l"/>
+          <a:bodyPr rtlCol="0" anchor="ctr" wrap="square" lIns="320040" tIns="164592"/>
+          <a:lstStyle/>
+          <a:p>
+            <a:pPr algn="ctr"/>
             <a:r>
               <a:rPr sz="2200" b="1">
                 <a:solidFill>
@@ -5486,14 +5740,14 @@
                 </a:solidFill>
                 <a:latin typeface="Calibri"/>
               </a:rPr>
-              <a:t>  No alcanza con FPR: mirar Precision y carga de revisión</a:t>
+              <a:t>6. Métrica de negocio: si revisamos Top-K, ¿cuántos fraudes?</a:t>
             </a:r>
           </a:p>
         </p:txBody>
       </p:sp>
       <p:pic>
         <p:nvPicPr>
-          <p:cNvPr id="3" name="Picture 2" descr="09_workload_aleatorio.png"/>
+          <p:cNvPr id="3" name="Picture 2" descr="08_captura_topk_aleatorio.png"/>
           <p:cNvPicPr>
             <a:picLocks noChangeAspect="1"/>
           </p:cNvPicPr>
@@ -5507,8 +5761,8 @@
         </p:blipFill>
         <p:spPr>
           <a:xfrm>
-            <a:off x="365760" y="1097280"/>
-            <a:ext cx="6583680" cy="3136997"/>
+            <a:off x="365760" y="1051560"/>
+            <a:ext cx="6583680" cy="3774231"/>
           </a:xfrm>
           <a:prstGeom prst="rect">
             <a:avLst/>
@@ -5523,7 +5777,7 @@
         </p:nvSpPr>
         <p:spPr>
           <a:xfrm>
-            <a:off x="7132320" y="1463040"/>
+            <a:off x="7132320" y="1371600"/>
             <a:ext cx="4572000" cy="4572000"/>
           </a:xfrm>
           <a:prstGeom prst="rect">
@@ -5532,88 +5786,104 @@
           <a:noFill/>
         </p:spPr>
         <p:txBody>
-          <a:bodyPr wrap="none">
+          <a:bodyPr wrap="square">
             <a:spAutoFit/>
           </a:bodyPr>
           <a:lstStyle/>
           <a:p>
             <a:pPr>
               <a:spcAft>
-                <a:spcPts val="600"/>
-              </a:spcAft>
-            </a:pPr>
-            <a:r>
-              <a:rPr sz="1500" b="0">
-                <a:solidFill>
-                  <a:srgbClr val="222222"/>
-                </a:solidFill>
-                <a:latin typeface="Calibri"/>
-              </a:rPr>
-              <a:t>FPR 5% sobre ~56,651 legítimas = miles de falsas alertas.</a:t>
-            </a:r>
-          </a:p>
-          <a:p>
-            <a:pPr>
-              <a:spcAft>
-                <a:spcPts val="600"/>
-              </a:spcAft>
-            </a:pPr>
-            <a:r>
-              <a:rPr sz="1500" b="0">
-                <a:solidFill>
-                  <a:srgbClr val="222222"/>
-                </a:solidFill>
-                <a:latin typeface="Calibri"/>
-              </a:rPr>
-              <a:t>Umbral elegido: 0.55</a:t>
-            </a:r>
-          </a:p>
-          <a:p>
-            <a:pPr>
-              <a:spcAft>
-                <a:spcPts val="600"/>
-              </a:spcAft>
-            </a:pPr>
-            <a:r>
-              <a:rPr sz="1500" b="0">
-                <a:solidFill>
-                  <a:srgbClr val="222222"/>
-                </a:solidFill>
-                <a:latin typeface="Calibri"/>
-              </a:rPr>
-              <a:t>Alertas a revisar: 88</a:t>
-            </a:r>
-          </a:p>
-          <a:p>
-            <a:pPr>
-              <a:spcAft>
-                <a:spcPts val="600"/>
-              </a:spcAft>
-            </a:pPr>
-            <a:r>
-              <a:rPr sz="1500" b="0">
-                <a:solidFill>
-                  <a:srgbClr val="222222"/>
-                </a:solidFill>
-                <a:latin typeface="Calibri"/>
-              </a:rPr>
-              <a:t>Recall 81.1% · Precision 87.5%</a:t>
-            </a:r>
-          </a:p>
-          <a:p>
-            <a:pPr>
-              <a:spcAft>
-                <a:spcPts val="600"/>
-              </a:spcAft>
-            </a:pPr>
-            <a:r>
-              <a:rPr sz="1500" b="0">
-                <a:solidFill>
-                  <a:srgbClr val="222222"/>
-                </a:solidFill>
-                <a:latin typeface="Calibri"/>
-              </a:rPr>
-              <a:t>TP=77 · FP=11 · FN=18</a:t>
+                <a:spcPts val="800"/>
+              </a:spcAft>
+            </a:pPr>
+            <a:r>
+              <a:rPr sz="1600" b="0">
+                <a:solidFill>
+                  <a:srgbClr val="222222"/>
+                </a:solidFill>
+                <a:latin typeface="Calibri"/>
+              </a:rPr>
+              <a:t>•  Top-100 → 77 fraudes</a:t>
+            </a:r>
+          </a:p>
+          <a:p>
+            <a:pPr>
+              <a:spcAft>
+                <a:spcPts val="800"/>
+              </a:spcAft>
+            </a:pPr>
+            <a:r>
+              <a:rPr sz="1600" b="0">
+                <a:solidFill>
+                  <a:srgbClr val="222222"/>
+                </a:solidFill>
+                <a:latin typeface="Calibri"/>
+              </a:rPr>
+              <a:t>•  Precision@100 = 77.0%</a:t>
+            </a:r>
+          </a:p>
+          <a:p>
+            <a:pPr>
+              <a:spcAft>
+                <a:spcPts val="800"/>
+              </a:spcAft>
+            </a:pPr>
+            <a:r>
+              <a:rPr sz="1600" b="0">
+                <a:solidFill>
+                  <a:srgbClr val="222222"/>
+                </a:solidFill>
+                <a:latin typeface="Calibri"/>
+              </a:rPr>
+              <a:t>•  Recall@100 = 81.1%</a:t>
+            </a:r>
+          </a:p>
+          <a:p>
+            <a:pPr>
+              <a:spcAft>
+                <a:spcPts val="800"/>
+              </a:spcAft>
+            </a:pPr>
+            <a:r>
+              <a:rPr sz="1600" b="0">
+                <a:solidFill>
+                  <a:srgbClr val="222222"/>
+                </a:solidFill>
+                <a:latin typeface="Calibri"/>
+              </a:rPr>
+              <a:t>•  Top-500 → 82 fraudes</a:t>
+            </a:r>
+          </a:p>
+          <a:p>
+            <a:pPr>
+              <a:spcAft>
+                <a:spcPts val="800"/>
+              </a:spcAft>
+            </a:pPr>
+            <a:r>
+              <a:rPr sz="1600" b="0">
+                <a:solidFill>
+                  <a:srgbClr val="222222"/>
+                </a:solidFill>
+                <a:latin typeface="Calibri"/>
+              </a:rPr>
+              <a:t>•  Lift@500 = 98.0×</a:t>
+            </a:r>
+          </a:p>
+          <a:p>
+            <a:pPr>
+              <a:spcAft>
+                <a:spcPts val="800"/>
+              </a:spcAft>
+            </a:pPr>
+            <a:r>
+              <a:rPr sz="1600" b="0">
+                <a:solidFill>
+                  <a:srgbClr val="222222"/>
+                </a:solidFill>
+                <a:latin typeface="Calibri"/>
+              </a:rPr>
+              <a:t>•  El score ordena la cola de revisión del equipo.</a:t>
             </a:r>
           </a:p>
         </p:txBody>
@@ -5626,8 +5896,8 @@
         </p:nvSpPr>
         <p:spPr>
           <a:xfrm>
-            <a:off x="365760" y="6492240"/>
-            <a:ext cx="11430000" cy="274320"/>
+            <a:off x="365760" y="6537960"/>
+            <a:ext cx="11430000" cy="256032"/>
           </a:xfrm>
           <a:prstGeom prst="rect">
             <a:avLst/>
@@ -5647,7 +5917,7 @@
                 </a:solidFill>
                 <a:latin typeface="Calibri"/>
               </a:rPr>
-              <a:t>Grupo 33 · Detección de Fraude · 8/12</a:t>
+              <a:t>Grupo 33 · Detección de Fraude en Tarjetas de Crédito · 8/12</a:t>
             </a:r>
           </a:p>
         </p:txBody>
@@ -5679,7 +5949,7 @@
         <p:spPr>
           <a:xfrm>
             <a:off x="0" y="0"/>
-            <a:ext cx="12191695" cy="822960"/>
+            <a:ext cx="12191695" cy="777240"/>
           </a:xfrm>
           <a:prstGeom prst="rect">
             <a:avLst/>
@@ -5706,10 +5976,10 @@
           </a:fontRef>
         </p:style>
         <p:txBody>
-          <a:bodyPr rtlCol="0" anchor="ctr"/>
-          <a:lstStyle/>
-          <a:p>
-            <a:pPr algn="l"/>
+          <a:bodyPr rtlCol="0" anchor="ctr" wrap="square" lIns="320040" tIns="164592"/>
+          <a:lstStyle/>
+          <a:p>
+            <a:pPr algn="ctr"/>
             <a:r>
               <a:rPr sz="2200" b="1">
                 <a:solidFill>
@@ -5717,14 +5987,14 @@
                 </a:solidFill>
                 <a:latin typeface="Calibri"/>
               </a:rPr>
-              <a:t>  Validación temporal vs aleatoria</a:t>
+              <a:t>7. Umbral operativo: Precision y carga real de alertas</a:t>
             </a:r>
           </a:p>
         </p:txBody>
       </p:sp>
       <p:pic>
         <p:nvPicPr>
-          <p:cNvPr id="3" name="Picture 2" descr="11_comparison_pr_auc.png"/>
+          <p:cNvPr id="3" name="Picture 2" descr="09_workload_aleatorio.png"/>
           <p:cNvPicPr>
             <a:picLocks noChangeAspect="1"/>
           </p:cNvPicPr>
@@ -5738,8 +6008,8 @@
         </p:blipFill>
         <p:spPr>
           <a:xfrm>
-            <a:off x="457200" y="1097280"/>
-            <a:ext cx="6858000" cy="3324079"/>
+            <a:off x="365760" y="1051560"/>
+            <a:ext cx="6583680" cy="3774231"/>
           </a:xfrm>
           <a:prstGeom prst="rect">
             <a:avLst/>
@@ -5754,8 +6024,8 @@
         </p:nvSpPr>
         <p:spPr>
           <a:xfrm>
-            <a:off x="7498079" y="1645920"/>
-            <a:ext cx="4206240" cy="4114800"/>
+            <a:off x="7132320" y="1280160"/>
+            <a:ext cx="4572000" cy="4754880"/>
           </a:xfrm>
           <a:prstGeom prst="rect">
             <a:avLst/>
@@ -5763,14 +6033,14 @@
           <a:noFill/>
         </p:spPr>
         <p:txBody>
-          <a:bodyPr wrap="none">
+          <a:bodyPr wrap="square">
             <a:spAutoFit/>
           </a:bodyPr>
           <a:lstStyle/>
           <a:p>
             <a:pPr>
               <a:spcAft>
-                <a:spcPts val="600"/>
+                <a:spcPts val="800"/>
               </a:spcAft>
             </a:pPr>
             <a:r>
@@ -5780,13 +6050,13 @@
                 </a:solidFill>
                 <a:latin typeface="Calibri"/>
               </a:rPr>
-              <a:t>Aleatorio: mezcla pasado/futuro.</a:t>
-            </a:r>
-          </a:p>
-          <a:p>
-            <a:pPr>
-              <a:spcAft>
-                <a:spcPts val="600"/>
+              <a:t>•  FPR 5 % ≈ 2,832 alertas falsas solo en el holdout.</a:t>
+            </a:r>
+          </a:p>
+          <a:p>
+            <a:pPr>
+              <a:spcAft>
+                <a:spcPts val="800"/>
               </a:spcAft>
             </a:pPr>
             <a:r>
@@ -5796,13 +6066,13 @@
                 </a:solidFill>
                 <a:latin typeface="Calibri"/>
               </a:rPr>
-              <a:t>Temporal: entrena con anteriores, prueba con posteriores.</a:t>
-            </a:r>
-          </a:p>
-          <a:p>
-            <a:pPr>
-              <a:spcAft>
-                <a:spcPts val="600"/>
+              <a:t>•  Umbral elegido: 0.55</a:t>
+            </a:r>
+          </a:p>
+          <a:p>
+            <a:pPr>
+              <a:spcAft>
+                <a:spcPts val="800"/>
               </a:spcAft>
             </a:pPr>
             <a:r>
@@ -5812,13 +6082,13 @@
                 </a:solidFill>
                 <a:latin typeface="Calibri"/>
               </a:rPr>
-              <a:t>Mejor temporal: RandomForest</a:t>
-            </a:r>
-          </a:p>
-          <a:p>
-            <a:pPr>
-              <a:spcAft>
-                <a:spcPts val="600"/>
+              <a:t>•  Alertas a revisar: 88</a:t>
+            </a:r>
+          </a:p>
+          <a:p>
+            <a:pPr>
+              <a:spcAft>
+                <a:spcPts val="800"/>
               </a:spcAft>
             </a:pPr>
             <a:r>
@@ -5828,13 +6098,13 @@
                 </a:solidFill>
                 <a:latin typeface="Calibri"/>
               </a:rPr>
-              <a:t>PR-AUC temporal: 0.813</a:t>
-            </a:r>
-          </a:p>
-          <a:p>
-            <a:pPr>
-              <a:spcAft>
-                <a:spcPts val="600"/>
+              <a:t>•  Recall 81.1% · Precision 87.5%</a:t>
+            </a:r>
+          </a:p>
+          <a:p>
+            <a:pPr>
+              <a:spcAft>
+                <a:spcPts val="800"/>
               </a:spcAft>
             </a:pPr>
             <a:r>
@@ -5844,7 +6114,23 @@
                 </a:solidFill>
                 <a:latin typeface="Calibri"/>
               </a:rPr>
-              <a:t>Más realista para despliegue.</a:t>
+              <a:t>•  TP=77 · FP=11 · FN=18</a:t>
+            </a:r>
+          </a:p>
+          <a:p>
+            <a:pPr>
+              <a:spcAft>
+                <a:spcPts val="800"/>
+              </a:spcAft>
+            </a:pPr>
+            <a:r>
+              <a:rPr sz="1500" b="0">
+                <a:solidFill>
+                  <a:srgbClr val="222222"/>
+                </a:solidFill>
+                <a:latin typeface="Calibri"/>
+              </a:rPr>
+              <a:t>•  No alcanza con controlar FPR: hay que mirar Precision y volumen.</a:t>
             </a:r>
           </a:p>
         </p:txBody>
@@ -5857,8 +6143,8 @@
         </p:nvSpPr>
         <p:spPr>
           <a:xfrm>
-            <a:off x="365760" y="6492240"/>
-            <a:ext cx="11430000" cy="274320"/>
+            <a:off x="365760" y="6537960"/>
+            <a:ext cx="11430000" cy="256032"/>
           </a:xfrm>
           <a:prstGeom prst="rect">
             <a:avLst/>
@@ -5878,7 +6164,7 @@
                 </a:solidFill>
                 <a:latin typeface="Calibri"/>
               </a:rPr>
-              <a:t>Grupo 33 · Detección de Fraude · 9/12</a:t>
+              <a:t>Grupo 33 · Detección de Fraude en Tarjetas de Crédito · 9/12</a:t>
             </a:r>
           </a:p>
         </p:txBody>

</xml_diff>